<commit_message>
Expand descriptions and explanations in report 2 and presentation
Progress report 2: split the project description into three subsections
covering the organization, the interviews and observation findings, the
proposed system and the report structure; added design rationale
(no-duplication and referential-integrity principles for the data model,
permission implications of the interfaces, uniform screen layout), richer
per-screen explanations tied to the analysis artifacts, and a lessons
section in the summary. Presentation: replaced stat cards with a plain
measures table, retitled slides in a more formal register, added an
explanatory caption to every diagram slide, and a course footer, keeping
it off slides with bottom captions to avoid collisions.

Co-Authored-By: Claude Fable 5 <noreply@anthropic.com>
Claude-Session: https://claude.ai/code/session_01QH1fisjM5swE6udW66xpfG
</commit_message>
<xml_diff>
--- a/project-documents/מצגת פרויקט - סא הנדסה.pptx
+++ b/project-documents/מצגת פרויקט - סא הנדסה.pptx
@@ -2488,7 +2488,7 @@
                 <a:ea typeface="Arial" pitchFamily="34" charset="-122"/>
                 <a:cs typeface="Arial" pitchFamily="34" charset="-120"/>
               </a:rPr>
-              <a:t>הישויות המרכזיות: עובדים, אתרים/קבלנים, שיבוצים, חשבוניות ושכר, והקשרים ביניהן</a:t>
+              <a:t>התרשים מגדיר את ישויות הליבה, עובדים, אתרים/קבלנים, שיבוצים, חשבוניות ושכר, את תכונותיהן ואת הקשרים ביניהן. בשלב העיצוב נגזר ממנו מבנה הטבלאות והמפתחות שיוצג בהמשך.</a:t>
             </a:r>
             <a:endParaRPr lang="en-US" sz="1400" dirty="0"/>
           </a:p>
@@ -4906,6 +4906,45 @@
           </a:p>
         </p:txBody>
       </p:sp>
+      <p:sp>
+        <p:nvSpPr>
+          <p:cNvPr id="6" name="Text 3"/>
+          <p:cNvSpPr/>
+          <p:nvPr/>
+        </p:nvSpPr>
+        <p:spPr>
+          <a:xfrm>
+            <a:off x="320040" y="6400800"/>
+            <a:ext cx="5120640" cy="274320"/>
+          </a:xfrm>
+          <a:prstGeom prst="rect">
+            <a:avLst/>
+          </a:prstGeom>
+          <a:noFill/>
+          <a:ln/>
+        </p:spPr>
+        <p:txBody>
+          <a:bodyPr wrap="square" lIns="0" tIns="0" rIns="0" bIns="0" rtlCol="0" anchor="ctr"/>
+          <a:lstStyle/>
+          <a:p>
+            <a:pPr rtl="1" algn="l" indent="0" marL="0">
+              <a:buNone/>
+            </a:pPr>
+            <a:r>
+              <a:rPr lang="en-US" sz="900" dirty="0">
+                <a:solidFill>
+                  <a:srgbClr val="9AA7A4"/>
+                </a:solidFill>
+                <a:latin typeface="Arial" pitchFamily="34" charset="0"/>
+                <a:ea typeface="Arial" pitchFamily="34" charset="-122"/>
+                <a:cs typeface="Arial" pitchFamily="34" charset="-120"/>
+              </a:rPr>
+              <a:t>פרקטיקום בניהול מערכות מידע, תשפ"ו | ס.א הנדסה | כאמל עואד</a:t>
+            </a:r>
+            <a:endParaRPr lang="en-US" sz="900" dirty="0"/>
+          </a:p>
+        </p:txBody>
+      </p:sp>
     </p:spTree>
   </p:cSld>
   <p:clrMapOvr>
@@ -4993,8 +5032,8 @@
         </p:blipFill>
         <p:spPr>
           <a:xfrm>
-            <a:off x="1737360" y="1371600"/>
-            <a:ext cx="8714232" cy="4983480"/>
+            <a:off x="1965960" y="1234440"/>
+            <a:ext cx="8257032" cy="4718304"/>
           </a:xfrm>
           <a:prstGeom prst="rect">
             <a:avLst/>
@@ -5004,6 +5043,45 @@
       <p:sp>
         <p:nvSpPr>
           <p:cNvPr id="4" name="Text 1"/>
+          <p:cNvSpPr/>
+          <p:nvPr/>
+        </p:nvSpPr>
+        <p:spPr>
+          <a:xfrm>
+            <a:off x="502920" y="6126480"/>
+            <a:ext cx="11183112" cy="548640"/>
+          </a:xfrm>
+          <a:prstGeom prst="rect">
+            <a:avLst/>
+          </a:prstGeom>
+          <a:noFill/>
+          <a:ln/>
+        </p:spPr>
+        <p:txBody>
+          <a:bodyPr wrap="square" lIns="0" tIns="0" rIns="0" bIns="0" rtlCol="0" anchor="ctr"/>
+          <a:lstStyle/>
+          <a:p>
+            <a:pPr rtl="1" algn="ctr" indent="0" marL="0">
+              <a:buNone/>
+            </a:pPr>
+            <a:r>
+              <a:rPr lang="en-US" sz="1300" dirty="0">
+                <a:solidFill>
+                  <a:srgbClr val="5B6B68"/>
+                </a:solidFill>
+                <a:latin typeface="Arial" pitchFamily="34" charset="0"/>
+                <a:ea typeface="Arial" pitchFamily="34" charset="-122"/>
+                <a:cs typeface="Arial" pitchFamily="34" charset="-120"/>
+              </a:rPr>
+              <a:t>חמישה ענפים תפעוליים הנגזרים מהטבלאות ומהתהליך. הגישה נקבעת לפי תפקיד: נציג השירות רואה את ענף הלקוחות, מנהל העבודה גם את העובדים והאתרים, וההנהלה את הכול, כולל שכר וכספים.</a:t>
+            </a:r>
+            <a:endParaRPr lang="en-US" sz="1300" dirty="0"/>
+          </a:p>
+        </p:txBody>
+      </p:sp>
+      <p:sp>
+        <p:nvSpPr>
+          <p:cNvPr id="5" name="Text 2"/>
           <p:cNvSpPr/>
           <p:nvPr/>
         </p:nvSpPr>
@@ -5969,6 +6047,45 @@
           </a:p>
         </p:txBody>
       </p:sp>
+      <p:sp>
+        <p:nvSpPr>
+          <p:cNvPr id="11" name="Text 9"/>
+          <p:cNvSpPr/>
+          <p:nvPr/>
+        </p:nvSpPr>
+        <p:spPr>
+          <a:xfrm>
+            <a:off x="320040" y="6400800"/>
+            <a:ext cx="5120640" cy="274320"/>
+          </a:xfrm>
+          <a:prstGeom prst="rect">
+            <a:avLst/>
+          </a:prstGeom>
+          <a:noFill/>
+          <a:ln/>
+        </p:spPr>
+        <p:txBody>
+          <a:bodyPr wrap="square" lIns="0" tIns="0" rIns="0" bIns="0" rtlCol="0" anchor="ctr"/>
+          <a:lstStyle/>
+          <a:p>
+            <a:pPr rtl="1" algn="l" indent="0" marL="0">
+              <a:buNone/>
+            </a:pPr>
+            <a:r>
+              <a:rPr lang="en-US" sz="900" dirty="0">
+                <a:solidFill>
+                  <a:srgbClr val="9AA7A4"/>
+                </a:solidFill>
+                <a:latin typeface="Arial" pitchFamily="34" charset="0"/>
+                <a:ea typeface="Arial" pitchFamily="34" charset="-122"/>
+                <a:cs typeface="Arial" pitchFamily="34" charset="-120"/>
+              </a:rPr>
+              <a:t>פרקטיקום בניהול מערכות מידע, תשפ"ו | ס.א הנדסה | כאמל עואד</a:t>
+            </a:r>
+            <a:endParaRPr lang="en-US" sz="900" dirty="0"/>
+          </a:p>
+        </p:txBody>
+      </p:sp>
     </p:spTree>
   </p:cSld>
   <p:clrMapOvr>
@@ -6410,6 +6527,45 @@
           </a:p>
         </p:txBody>
       </p:sp>
+      <p:sp>
+        <p:nvSpPr>
+          <p:cNvPr id="10" name="Text 8"/>
+          <p:cNvSpPr/>
+          <p:nvPr/>
+        </p:nvSpPr>
+        <p:spPr>
+          <a:xfrm>
+            <a:off x="320040" y="6400800"/>
+            <a:ext cx="5120640" cy="274320"/>
+          </a:xfrm>
+          <a:prstGeom prst="rect">
+            <a:avLst/>
+          </a:prstGeom>
+          <a:noFill/>
+          <a:ln/>
+        </p:spPr>
+        <p:txBody>
+          <a:bodyPr wrap="square" lIns="0" tIns="0" rIns="0" bIns="0" rtlCol="0" anchor="ctr"/>
+          <a:lstStyle/>
+          <a:p>
+            <a:pPr rtl="1" algn="l" indent="0" marL="0">
+              <a:buNone/>
+            </a:pPr>
+            <a:r>
+              <a:rPr lang="en-US" sz="900" dirty="0">
+                <a:solidFill>
+                  <a:srgbClr val="9AA7A4"/>
+                </a:solidFill>
+                <a:latin typeface="Arial" pitchFamily="34" charset="0"/>
+                <a:ea typeface="Arial" pitchFamily="34" charset="-122"/>
+                <a:cs typeface="Arial" pitchFamily="34" charset="-120"/>
+              </a:rPr>
+              <a:t>פרקטיקום בניהול מערכות מידע, תשפ"ו | ס.א הנדסה | כאמל עואד</a:t>
+            </a:r>
+            <a:endParaRPr lang="en-US" sz="900" dirty="0"/>
+          </a:p>
+        </p:txBody>
+      </p:sp>
     </p:spTree>
   </p:cSld>
   <p:clrMapOvr>
@@ -6983,6 +7139,45 @@
           </a:p>
         </p:txBody>
       </p:sp>
+      <p:sp>
+        <p:nvSpPr>
+          <p:cNvPr id="18" name="Text 15"/>
+          <p:cNvSpPr/>
+          <p:nvPr/>
+        </p:nvSpPr>
+        <p:spPr>
+          <a:xfrm>
+            <a:off x="320040" y="6400800"/>
+            <a:ext cx="5120640" cy="274320"/>
+          </a:xfrm>
+          <a:prstGeom prst="rect">
+            <a:avLst/>
+          </a:prstGeom>
+          <a:noFill/>
+          <a:ln/>
+        </p:spPr>
+        <p:txBody>
+          <a:bodyPr wrap="square" lIns="0" tIns="0" rIns="0" bIns="0" rtlCol="0" anchor="ctr"/>
+          <a:lstStyle/>
+          <a:p>
+            <a:pPr rtl="1" algn="l" indent="0" marL="0">
+              <a:buNone/>
+            </a:pPr>
+            <a:r>
+              <a:rPr lang="en-US" sz="900" dirty="0">
+                <a:solidFill>
+                  <a:srgbClr val="9AA7A4"/>
+                </a:solidFill>
+                <a:latin typeface="Arial" pitchFamily="34" charset="0"/>
+                <a:ea typeface="Arial" pitchFamily="34" charset="-122"/>
+                <a:cs typeface="Arial" pitchFamily="34" charset="-120"/>
+              </a:rPr>
+              <a:t>פרקטיקום בניהול מערכות מידע, תשפ"ו | ס.א הנדסה | כאמל עואד</a:t>
+            </a:r>
+            <a:endParaRPr lang="en-US" sz="900" dirty="0"/>
+          </a:p>
+        </p:txBody>
+      </p:sp>
     </p:spTree>
   </p:cSld>
   <p:clrMapOvr>
@@ -7048,7 +7243,7 @@
                 <a:ea typeface="Arial" pitchFamily="34" charset="-122"/>
                 <a:cs typeface="Arial" pitchFamily="34" charset="-120"/>
               </a:rPr>
-              <a:t>המצב הקיים: הכול מנוהל ביד</a:t>
+              <a:t>ניתוח המצב הקיים ובעיותיו</a:t>
             </a:r>
             <a:endParaRPr lang="en-US" sz="3000" dirty="0"/>
           </a:p>
@@ -7087,7 +7282,7 @@
                 <a:ea typeface="Arial" pitchFamily="34" charset="-122"/>
                 <a:cs typeface="Arial" pitchFamily="34" charset="-120"/>
               </a:rPr>
-              <a:t>אין כלי ממוחשב מרכזי; העבודה מתנהלת בטלפון, בהודעות וברישומים מפוזרים</a:t>
+              <a:t>מהראיונות עם בעל החברה והעובדים ומתצפית על יום עבודה עלו ארבע בעיות מרכזיות, כולן תוצאה של ניהול ידני ללא כלי ממוחשב מרכזי:</a:t>
             </a:r>
             <a:endParaRPr lang="en-US" sz="1600" dirty="0"/>
           </a:p>
@@ -7765,6 +7960,45 @@
               <a:t>3</a:t>
             </a:r>
             <a:endParaRPr lang="en-US" sz="1000" dirty="0"/>
+          </a:p>
+        </p:txBody>
+      </p:sp>
+      <p:sp>
+        <p:nvSpPr>
+          <p:cNvPr id="25" name="Text 23"/>
+          <p:cNvSpPr/>
+          <p:nvPr/>
+        </p:nvSpPr>
+        <p:spPr>
+          <a:xfrm>
+            <a:off x="320040" y="6400800"/>
+            <a:ext cx="5120640" cy="274320"/>
+          </a:xfrm>
+          <a:prstGeom prst="rect">
+            <a:avLst/>
+          </a:prstGeom>
+          <a:noFill/>
+          <a:ln/>
+        </p:spPr>
+        <p:txBody>
+          <a:bodyPr wrap="square" lIns="0" tIns="0" rIns="0" bIns="0" rtlCol="0" anchor="ctr"/>
+          <a:lstStyle/>
+          <a:p>
+            <a:pPr rtl="1" algn="l" indent="0" marL="0">
+              <a:buNone/>
+            </a:pPr>
+            <a:r>
+              <a:rPr lang="en-US" sz="900" dirty="0">
+                <a:solidFill>
+                  <a:srgbClr val="9AA7A4"/>
+                </a:solidFill>
+                <a:latin typeface="Arial" pitchFamily="34" charset="0"/>
+                <a:ea typeface="Arial" pitchFamily="34" charset="-122"/>
+                <a:cs typeface="Arial" pitchFamily="34" charset="-120"/>
+              </a:rPr>
+              <a:t>פרקטיקום בניהול מערכות מידע, תשפ"ו | ס.א הנדסה | כאמל עואד</a:t>
+            </a:r>
+            <a:endParaRPr lang="en-US" sz="900" dirty="0"/>
           </a:p>
         </p:txBody>
       </p:sp>
@@ -7847,8 +8081,8 @@
         </p:nvSpPr>
         <p:spPr>
           <a:xfrm>
-            <a:off x="502920" y="1024128"/>
-            <a:ext cx="11183112" cy="685800"/>
+            <a:off x="502920" y="1051560"/>
+            <a:ext cx="11183112" cy="777240"/>
           </a:xfrm>
           <a:prstGeom prst="rect">
             <a:avLst/>
@@ -7864,7 +8098,7 @@
               <a:buNone/>
             </a:pPr>
             <a:r>
-              <a:rPr lang="en-US" sz="1700" dirty="0">
+              <a:rPr lang="en-US" sz="1600" dirty="0">
                 <a:solidFill>
                   <a:srgbClr val="1F2937"/>
                 </a:solidFill>
@@ -7872,734 +8106,1495 @@
                 <a:ea typeface="Arial" pitchFamily="34" charset="-122"/>
                 <a:cs typeface="Arial" pitchFamily="34" charset="-120"/>
               </a:rPr>
-              <a:t>ניתוח, איפיון ועיצוב של מערכת מידע מרכזית שמנהלת את כל מחזור הטיפול בבקשה: מקליטת הפנייה ועד החשבונית והשכר</a:t>
-            </a:r>
-            <a:endParaRPr lang="en-US" sz="1700" dirty="0"/>
-          </a:p>
-        </p:txBody>
-      </p:sp>
-      <p:sp>
-        <p:nvSpPr>
-          <p:cNvPr id="4" name="Shape 2"/>
-          <p:cNvSpPr/>
-          <p:nvPr/>
-        </p:nvSpPr>
-        <p:spPr>
-          <a:xfrm>
-            <a:off x="9015984" y="2057400"/>
-            <a:ext cx="2670048" cy="2834640"/>
-          </a:xfrm>
-          <a:prstGeom prst="roundRect">
-            <a:avLst>
-              <a:gd name="adj" fmla="val 2740"/>
-            </a:avLst>
-          </a:prstGeom>
-          <a:solidFill>
-            <a:srgbClr val="EAF4F2"/>
-          </a:solidFill>
-          <a:ln/>
-        </p:spPr>
-      </p:sp>
-      <p:sp>
-        <p:nvSpPr>
-          <p:cNvPr id="5" name="Text 3"/>
-          <p:cNvSpPr/>
-          <p:nvPr/>
-        </p:nvSpPr>
-        <p:spPr>
-          <a:xfrm>
-            <a:off x="9153144" y="2258568"/>
-            <a:ext cx="2395728" cy="457200"/>
-          </a:xfrm>
-          <a:prstGeom prst="rect">
-            <a:avLst/>
-          </a:prstGeom>
-          <a:noFill/>
-          <a:ln/>
-        </p:spPr>
-        <p:txBody>
-          <a:bodyPr wrap="square" lIns="0" tIns="0" rIns="0" bIns="0" rtlCol="0" anchor="ctr"/>
-          <a:lstStyle/>
-          <a:p>
-            <a:pPr rtl="1" algn="ctr" indent="0" marL="0">
-              <a:buNone/>
-            </a:pPr>
-            <a:r>
-              <a:rPr lang="en-US" sz="1500" b="1" dirty="0">
-                <a:solidFill>
-                  <a:srgbClr val="0F4C46"/>
-                </a:solidFill>
-                <a:latin typeface="Arial" pitchFamily="34" charset="0"/>
-                <a:ea typeface="Arial" pitchFamily="34" charset="-122"/>
-                <a:cs typeface="Arial" pitchFamily="34" charset="-120"/>
-              </a:rPr>
-              <a:t>קליטת בקשה</a:t>
-            </a:r>
-            <a:endParaRPr lang="en-US" sz="1500" dirty="0"/>
-          </a:p>
-        </p:txBody>
-      </p:sp>
-      <p:sp>
-        <p:nvSpPr>
-          <p:cNvPr id="6" name="Text 4"/>
-          <p:cNvSpPr/>
-          <p:nvPr/>
-        </p:nvSpPr>
-        <p:spPr>
-          <a:xfrm>
-            <a:off x="9153144" y="2834640"/>
-            <a:ext cx="2395728" cy="502920"/>
-          </a:xfrm>
-          <a:prstGeom prst="rect">
-            <a:avLst/>
-          </a:prstGeom>
-          <a:noFill/>
-          <a:ln/>
-        </p:spPr>
-        <p:txBody>
-          <a:bodyPr wrap="square" lIns="0" tIns="0" rIns="0" bIns="0" rtlCol="0" anchor="ctr"/>
-          <a:lstStyle/>
-          <a:p>
-            <a:pPr rtl="1" algn="ctr" indent="0" marL="0">
-              <a:buNone/>
-            </a:pPr>
-            <a:r>
-              <a:rPr lang="en-US" sz="2000" strike="sngStrike" dirty="0">
-                <a:solidFill>
-                  <a:srgbClr val="5B6B68"/>
-                </a:solidFill>
-                <a:latin typeface="Arial" pitchFamily="34" charset="0"/>
-                <a:ea typeface="Arial" pitchFamily="34" charset="-122"/>
-                <a:cs typeface="Arial" pitchFamily="34" charset="-120"/>
-              </a:rPr>
-              <a:t>20 דק׳</a:t>
-            </a:r>
-            <a:endParaRPr lang="en-US" sz="2000" dirty="0"/>
-          </a:p>
-        </p:txBody>
-      </p:sp>
-      <p:sp>
-        <p:nvSpPr>
-          <p:cNvPr id="7" name="Text 5"/>
-          <p:cNvSpPr/>
-          <p:nvPr/>
-        </p:nvSpPr>
-        <p:spPr>
-          <a:xfrm>
-            <a:off x="9153144" y="3429000"/>
-            <a:ext cx="2395728" cy="731520"/>
-          </a:xfrm>
-          <a:prstGeom prst="rect">
-            <a:avLst/>
-          </a:prstGeom>
-          <a:noFill/>
-          <a:ln/>
-        </p:spPr>
-        <p:txBody>
-          <a:bodyPr wrap="square" lIns="0" tIns="0" rIns="0" bIns="0" rtlCol="0" anchor="ctr"/>
-          <a:lstStyle/>
-          <a:p>
-            <a:pPr rtl="1" algn="ctr" indent="0" marL="0">
-              <a:buNone/>
-            </a:pPr>
-            <a:r>
-              <a:rPr lang="en-US" sz="3000" b="1" dirty="0">
-                <a:solidFill>
-                  <a:srgbClr val="E8862E"/>
-                </a:solidFill>
-                <a:latin typeface="Arial" pitchFamily="34" charset="0"/>
-                <a:ea typeface="Arial" pitchFamily="34" charset="-122"/>
-                <a:cs typeface="Arial" pitchFamily="34" charset="-120"/>
-              </a:rPr>
-              <a:t>5 דק׳</a:t>
-            </a:r>
-            <a:endParaRPr lang="en-US" sz="3000" dirty="0"/>
-          </a:p>
-        </p:txBody>
-      </p:sp>
-      <p:sp>
-        <p:nvSpPr>
-          <p:cNvPr id="8" name="Text 6"/>
-          <p:cNvSpPr/>
-          <p:nvPr/>
-        </p:nvSpPr>
-        <p:spPr>
-          <a:xfrm>
-            <a:off x="9153144" y="4343400"/>
-            <a:ext cx="2395728" cy="320040"/>
-          </a:xfrm>
-          <a:prstGeom prst="rect">
-            <a:avLst/>
-          </a:prstGeom>
-          <a:noFill/>
-          <a:ln/>
-        </p:spPr>
-        <p:txBody>
-          <a:bodyPr wrap="square" lIns="0" tIns="0" rIns="0" bIns="0" rtlCol="0" anchor="ctr"/>
-          <a:lstStyle/>
-          <a:p>
-            <a:pPr rtl="1" algn="ctr" indent="0" marL="0">
-              <a:buNone/>
-            </a:pPr>
-            <a:r>
-              <a:rPr lang="en-US" sz="1100" dirty="0">
-                <a:solidFill>
-                  <a:srgbClr val="5B6B68"/>
-                </a:solidFill>
-                <a:latin typeface="Arial" pitchFamily="34" charset="0"/>
-                <a:ea typeface="Arial" pitchFamily="34" charset="-122"/>
-                <a:cs typeface="Arial" pitchFamily="34" charset="-120"/>
-              </a:rPr>
-              <a:t>היעד לאחר המערכת</a:t>
-            </a:r>
-            <a:endParaRPr lang="en-US" sz="1100" dirty="0"/>
-          </a:p>
-        </p:txBody>
-      </p:sp>
-      <p:sp>
-        <p:nvSpPr>
-          <p:cNvPr id="9" name="Shape 7"/>
-          <p:cNvSpPr/>
-          <p:nvPr/>
-        </p:nvSpPr>
-        <p:spPr>
-          <a:xfrm>
-            <a:off x="6181344" y="2057400"/>
-            <a:ext cx="2670048" cy="2834640"/>
-          </a:xfrm>
-          <a:prstGeom prst="roundRect">
-            <a:avLst>
-              <a:gd name="adj" fmla="val 2740"/>
-            </a:avLst>
-          </a:prstGeom>
-          <a:solidFill>
-            <a:srgbClr val="EAF4F2"/>
-          </a:solidFill>
-          <a:ln/>
-        </p:spPr>
-      </p:sp>
-      <p:sp>
-        <p:nvSpPr>
-          <p:cNvPr id="10" name="Text 8"/>
-          <p:cNvSpPr/>
-          <p:nvPr/>
-        </p:nvSpPr>
-        <p:spPr>
-          <a:xfrm>
-            <a:off x="6318504" y="2258568"/>
-            <a:ext cx="2395728" cy="457200"/>
-          </a:xfrm>
-          <a:prstGeom prst="rect">
-            <a:avLst/>
-          </a:prstGeom>
-          <a:noFill/>
-          <a:ln/>
-        </p:spPr>
-        <p:txBody>
-          <a:bodyPr wrap="square" lIns="0" tIns="0" rIns="0" bIns="0" rtlCol="0" anchor="ctr"/>
-          <a:lstStyle/>
-          <a:p>
-            <a:pPr rtl="1" algn="ctr" indent="0" marL="0">
-              <a:buNone/>
-            </a:pPr>
-            <a:r>
-              <a:rPr lang="en-US" sz="1500" b="1" dirty="0">
-                <a:solidFill>
-                  <a:srgbClr val="0F4C46"/>
-                </a:solidFill>
-                <a:latin typeface="Arial" pitchFamily="34" charset="0"/>
-                <a:ea typeface="Arial" pitchFamily="34" charset="-122"/>
-                <a:cs typeface="Arial" pitchFamily="34" charset="-120"/>
-              </a:rPr>
-              <a:t>הכנת הצעת מחיר</a:t>
-            </a:r>
-            <a:endParaRPr lang="en-US" sz="1500" dirty="0"/>
-          </a:p>
-        </p:txBody>
-      </p:sp>
-      <p:sp>
-        <p:nvSpPr>
-          <p:cNvPr id="11" name="Text 9"/>
-          <p:cNvSpPr/>
-          <p:nvPr/>
-        </p:nvSpPr>
-        <p:spPr>
-          <a:xfrm>
-            <a:off x="6318504" y="2834640"/>
-            <a:ext cx="2395728" cy="502920"/>
-          </a:xfrm>
-          <a:prstGeom prst="rect">
-            <a:avLst/>
-          </a:prstGeom>
-          <a:noFill/>
-          <a:ln/>
-        </p:spPr>
-        <p:txBody>
-          <a:bodyPr wrap="square" lIns="0" tIns="0" rIns="0" bIns="0" rtlCol="0" anchor="ctr"/>
-          <a:lstStyle/>
-          <a:p>
-            <a:pPr rtl="1" algn="ctr" indent="0" marL="0">
-              <a:buNone/>
-            </a:pPr>
-            <a:r>
-              <a:rPr lang="en-US" sz="2000" strike="sngStrike" dirty="0">
-                <a:solidFill>
-                  <a:srgbClr val="5B6B68"/>
-                </a:solidFill>
-                <a:latin typeface="Arial" pitchFamily="34" charset="0"/>
-                <a:ea typeface="Arial" pitchFamily="34" charset="-122"/>
-                <a:cs typeface="Arial" pitchFamily="34" charset="-120"/>
-              </a:rPr>
-              <a:t>2-3 ימים</a:t>
-            </a:r>
-            <a:endParaRPr lang="en-US" sz="2000" dirty="0"/>
-          </a:p>
-        </p:txBody>
-      </p:sp>
-      <p:sp>
-        <p:nvSpPr>
-          <p:cNvPr id="12" name="Text 10"/>
-          <p:cNvSpPr/>
-          <p:nvPr/>
-        </p:nvSpPr>
-        <p:spPr>
-          <a:xfrm>
-            <a:off x="6318504" y="3429000"/>
-            <a:ext cx="2395728" cy="731520"/>
-          </a:xfrm>
-          <a:prstGeom prst="rect">
-            <a:avLst/>
-          </a:prstGeom>
-          <a:noFill/>
-          <a:ln/>
-        </p:spPr>
-        <p:txBody>
-          <a:bodyPr wrap="square" lIns="0" tIns="0" rIns="0" bIns="0" rtlCol="0" anchor="ctr"/>
-          <a:lstStyle/>
-          <a:p>
-            <a:pPr rtl="1" algn="ctr" indent="0" marL="0">
-              <a:buNone/>
-            </a:pPr>
-            <a:r>
-              <a:rPr lang="en-US" sz="3000" b="1" dirty="0">
-                <a:solidFill>
-                  <a:srgbClr val="E8862E"/>
-                </a:solidFill>
-                <a:latin typeface="Arial" pitchFamily="34" charset="0"/>
-                <a:ea typeface="Arial" pitchFamily="34" charset="-122"/>
-                <a:cs typeface="Arial" pitchFamily="34" charset="-120"/>
-              </a:rPr>
-              <a:t>יום אחד</a:t>
-            </a:r>
-            <a:endParaRPr lang="en-US" sz="3000" dirty="0"/>
-          </a:p>
-        </p:txBody>
-      </p:sp>
-      <p:sp>
-        <p:nvSpPr>
-          <p:cNvPr id="13" name="Text 11"/>
-          <p:cNvSpPr/>
-          <p:nvPr/>
-        </p:nvSpPr>
-        <p:spPr>
-          <a:xfrm>
-            <a:off x="6318504" y="4343400"/>
-            <a:ext cx="2395728" cy="320040"/>
-          </a:xfrm>
-          <a:prstGeom prst="rect">
-            <a:avLst/>
-          </a:prstGeom>
-          <a:noFill/>
-          <a:ln/>
-        </p:spPr>
-        <p:txBody>
-          <a:bodyPr wrap="square" lIns="0" tIns="0" rIns="0" bIns="0" rtlCol="0" anchor="ctr"/>
-          <a:lstStyle/>
-          <a:p>
-            <a:pPr rtl="1" algn="ctr" indent="0" marL="0">
-              <a:buNone/>
-            </a:pPr>
-            <a:r>
-              <a:rPr lang="en-US" sz="1100" dirty="0">
-                <a:solidFill>
-                  <a:srgbClr val="5B6B68"/>
-                </a:solidFill>
-                <a:latin typeface="Arial" pitchFamily="34" charset="0"/>
-                <a:ea typeface="Arial" pitchFamily="34" charset="-122"/>
-                <a:cs typeface="Arial" pitchFamily="34" charset="-120"/>
-              </a:rPr>
-              <a:t>היעד לאחר המערכת</a:t>
-            </a:r>
-            <a:endParaRPr lang="en-US" sz="1100" dirty="0"/>
-          </a:p>
-        </p:txBody>
-      </p:sp>
-      <p:sp>
-        <p:nvSpPr>
-          <p:cNvPr id="14" name="Shape 12"/>
-          <p:cNvSpPr/>
-          <p:nvPr/>
-        </p:nvSpPr>
-        <p:spPr>
-          <a:xfrm>
-            <a:off x="3346704" y="2057400"/>
-            <a:ext cx="2670048" cy="2834640"/>
-          </a:xfrm>
-          <a:prstGeom prst="roundRect">
-            <a:avLst>
-              <a:gd name="adj" fmla="val 2740"/>
-            </a:avLst>
-          </a:prstGeom>
-          <a:solidFill>
-            <a:srgbClr val="EAF4F2"/>
-          </a:solidFill>
-          <a:ln/>
-        </p:spPr>
-      </p:sp>
-      <p:sp>
-        <p:nvSpPr>
-          <p:cNvPr id="15" name="Text 13"/>
-          <p:cNvSpPr/>
-          <p:nvPr/>
-        </p:nvSpPr>
-        <p:spPr>
-          <a:xfrm>
-            <a:off x="3483864" y="2258568"/>
-            <a:ext cx="2395728" cy="457200"/>
-          </a:xfrm>
-          <a:prstGeom prst="rect">
-            <a:avLst/>
-          </a:prstGeom>
-          <a:noFill/>
-          <a:ln/>
-        </p:spPr>
-        <p:txBody>
-          <a:bodyPr wrap="square" lIns="0" tIns="0" rIns="0" bIns="0" rtlCol="0" anchor="ctr"/>
-          <a:lstStyle/>
-          <a:p>
-            <a:pPr rtl="1" algn="ctr" indent="0" marL="0">
-              <a:buNone/>
-            </a:pPr>
-            <a:r>
-              <a:rPr lang="en-US" sz="1500" b="1" dirty="0">
-                <a:solidFill>
-                  <a:srgbClr val="0F4C46"/>
-                </a:solidFill>
-                <a:latin typeface="Arial" pitchFamily="34" charset="0"/>
-                <a:ea typeface="Arial" pitchFamily="34" charset="-122"/>
-                <a:cs typeface="Arial" pitchFamily="34" charset="-120"/>
-              </a:rPr>
-              <a:t>דוח שכר חודשי</a:t>
-            </a:r>
-            <a:endParaRPr lang="en-US" sz="1500" dirty="0"/>
-          </a:p>
-        </p:txBody>
-      </p:sp>
-      <p:sp>
-        <p:nvSpPr>
-          <p:cNvPr id="16" name="Text 14"/>
-          <p:cNvSpPr/>
-          <p:nvPr/>
-        </p:nvSpPr>
-        <p:spPr>
-          <a:xfrm>
-            <a:off x="3483864" y="2834640"/>
-            <a:ext cx="2395728" cy="502920"/>
-          </a:xfrm>
-          <a:prstGeom prst="rect">
-            <a:avLst/>
-          </a:prstGeom>
-          <a:noFill/>
-          <a:ln/>
-        </p:spPr>
-        <p:txBody>
-          <a:bodyPr wrap="square" lIns="0" tIns="0" rIns="0" bIns="0" rtlCol="0" anchor="ctr"/>
-          <a:lstStyle/>
-          <a:p>
-            <a:pPr rtl="1" algn="ctr" indent="0" marL="0">
-              <a:buNone/>
-            </a:pPr>
-            <a:r>
-              <a:rPr lang="en-US" sz="2000" strike="sngStrike" dirty="0">
-                <a:solidFill>
-                  <a:srgbClr val="5B6B68"/>
-                </a:solidFill>
-                <a:latin typeface="Arial" pitchFamily="34" charset="0"/>
-                <a:ea typeface="Arial" pitchFamily="34" charset="-122"/>
-                <a:cs typeface="Arial" pitchFamily="34" charset="-120"/>
-              </a:rPr>
-              <a:t>יום מלא</a:t>
-            </a:r>
-            <a:endParaRPr lang="en-US" sz="2000" dirty="0"/>
-          </a:p>
-        </p:txBody>
-      </p:sp>
-      <p:sp>
-        <p:nvSpPr>
-          <p:cNvPr id="17" name="Text 15"/>
-          <p:cNvSpPr/>
-          <p:nvPr/>
-        </p:nvSpPr>
-        <p:spPr>
-          <a:xfrm>
-            <a:off x="3483864" y="3429000"/>
-            <a:ext cx="2395728" cy="731520"/>
-          </a:xfrm>
-          <a:prstGeom prst="rect">
-            <a:avLst/>
-          </a:prstGeom>
-          <a:noFill/>
-          <a:ln/>
-        </p:spPr>
-        <p:txBody>
-          <a:bodyPr wrap="square" lIns="0" tIns="0" rIns="0" bIns="0" rtlCol="0" anchor="ctr"/>
-          <a:lstStyle/>
-          <a:p>
-            <a:pPr rtl="1" algn="ctr" indent="0" marL="0">
-              <a:buNone/>
-            </a:pPr>
-            <a:r>
-              <a:rPr lang="en-US" sz="3000" b="1" dirty="0">
-                <a:solidFill>
-                  <a:srgbClr val="E8862E"/>
-                </a:solidFill>
-                <a:latin typeface="Arial" pitchFamily="34" charset="0"/>
-                <a:ea typeface="Arial" pitchFamily="34" charset="-122"/>
-                <a:cs typeface="Arial" pitchFamily="34" charset="-120"/>
-              </a:rPr>
-              <a:t>עד שעה</a:t>
-            </a:r>
-            <a:endParaRPr lang="en-US" sz="3000" dirty="0"/>
-          </a:p>
-        </p:txBody>
-      </p:sp>
-      <p:sp>
-        <p:nvSpPr>
-          <p:cNvPr id="18" name="Text 16"/>
-          <p:cNvSpPr/>
-          <p:nvPr/>
-        </p:nvSpPr>
-        <p:spPr>
-          <a:xfrm>
-            <a:off x="3483864" y="4343400"/>
-            <a:ext cx="2395728" cy="320040"/>
-          </a:xfrm>
-          <a:prstGeom prst="rect">
-            <a:avLst/>
-          </a:prstGeom>
-          <a:noFill/>
-          <a:ln/>
-        </p:spPr>
-        <p:txBody>
-          <a:bodyPr wrap="square" lIns="0" tIns="0" rIns="0" bIns="0" rtlCol="0" anchor="ctr"/>
-          <a:lstStyle/>
-          <a:p>
-            <a:pPr rtl="1" algn="ctr" indent="0" marL="0">
-              <a:buNone/>
-            </a:pPr>
-            <a:r>
-              <a:rPr lang="en-US" sz="1100" dirty="0">
-                <a:solidFill>
-                  <a:srgbClr val="5B6B68"/>
-                </a:solidFill>
-                <a:latin typeface="Arial" pitchFamily="34" charset="0"/>
-                <a:ea typeface="Arial" pitchFamily="34" charset="-122"/>
-                <a:cs typeface="Arial" pitchFamily="34" charset="-120"/>
-              </a:rPr>
-              <a:t>היעד לאחר המערכת</a:t>
-            </a:r>
-            <a:endParaRPr lang="en-US" sz="1100" dirty="0"/>
-          </a:p>
-        </p:txBody>
-      </p:sp>
-      <p:sp>
-        <p:nvSpPr>
-          <p:cNvPr id="19" name="Shape 17"/>
-          <p:cNvSpPr/>
-          <p:nvPr/>
-        </p:nvSpPr>
-        <p:spPr>
-          <a:xfrm>
-            <a:off x="512064" y="2057400"/>
-            <a:ext cx="2670048" cy="2834640"/>
-          </a:xfrm>
-          <a:prstGeom prst="roundRect">
-            <a:avLst>
-              <a:gd name="adj" fmla="val 2740"/>
-            </a:avLst>
-          </a:prstGeom>
-          <a:solidFill>
-            <a:srgbClr val="EAF4F2"/>
-          </a:solidFill>
-          <a:ln/>
-        </p:spPr>
-      </p:sp>
-      <p:sp>
-        <p:nvSpPr>
-          <p:cNvPr id="20" name="Text 18"/>
-          <p:cNvSpPr/>
-          <p:nvPr/>
-        </p:nvSpPr>
-        <p:spPr>
-          <a:xfrm>
-            <a:off x="649224" y="2258568"/>
-            <a:ext cx="2395728" cy="457200"/>
-          </a:xfrm>
-          <a:prstGeom prst="rect">
-            <a:avLst/>
-          </a:prstGeom>
-          <a:noFill/>
-          <a:ln/>
-        </p:spPr>
-        <p:txBody>
-          <a:bodyPr wrap="square" lIns="0" tIns="0" rIns="0" bIns="0" rtlCol="0" anchor="ctr"/>
-          <a:lstStyle/>
-          <a:p>
-            <a:pPr rtl="1" algn="ctr" indent="0" marL="0">
-              <a:buNone/>
-            </a:pPr>
-            <a:r>
-              <a:rPr lang="en-US" sz="1500" b="1" dirty="0">
-                <a:solidFill>
-                  <a:srgbClr val="0F4C46"/>
-                </a:solidFill>
-                <a:latin typeface="Arial" pitchFamily="34" charset="0"/>
-                <a:ea typeface="Arial" pitchFamily="34" charset="-122"/>
-                <a:cs typeface="Arial" pitchFamily="34" charset="-120"/>
-              </a:rPr>
-              <a:t>אובדן / כפילות רישום</a:t>
-            </a:r>
-            <a:endParaRPr lang="en-US" sz="1500" dirty="0"/>
-          </a:p>
-        </p:txBody>
-      </p:sp>
-      <p:sp>
-        <p:nvSpPr>
-          <p:cNvPr id="21" name="Text 19"/>
-          <p:cNvSpPr/>
-          <p:nvPr/>
-        </p:nvSpPr>
-        <p:spPr>
-          <a:xfrm>
-            <a:off x="649224" y="2834640"/>
-            <a:ext cx="2395728" cy="502920"/>
-          </a:xfrm>
-          <a:prstGeom prst="rect">
-            <a:avLst/>
-          </a:prstGeom>
-          <a:noFill/>
-          <a:ln/>
-        </p:spPr>
-        <p:txBody>
-          <a:bodyPr wrap="square" lIns="0" tIns="0" rIns="0" bIns="0" rtlCol="0" anchor="ctr"/>
-          <a:lstStyle/>
-          <a:p>
-            <a:pPr rtl="1" algn="ctr" indent="0" marL="0">
-              <a:buNone/>
-            </a:pPr>
-            <a:r>
-              <a:rPr lang="en-US" sz="2000" strike="sngStrike" dirty="0">
-                <a:solidFill>
-                  <a:srgbClr val="5B6B68"/>
-                </a:solidFill>
-                <a:latin typeface="Arial" pitchFamily="34" charset="0"/>
-                <a:ea typeface="Arial" pitchFamily="34" charset="-122"/>
-                <a:cs typeface="Arial" pitchFamily="34" charset="-120"/>
-              </a:rPr>
-              <a:t>מדי חודש</a:t>
-            </a:r>
-            <a:endParaRPr lang="en-US" sz="2000" dirty="0"/>
-          </a:p>
-        </p:txBody>
-      </p:sp>
-      <p:sp>
-        <p:nvSpPr>
-          <p:cNvPr id="22" name="Text 20"/>
-          <p:cNvSpPr/>
-          <p:nvPr/>
-        </p:nvSpPr>
-        <p:spPr>
-          <a:xfrm>
-            <a:off x="649224" y="3429000"/>
-            <a:ext cx="2395728" cy="731520"/>
-          </a:xfrm>
-          <a:prstGeom prst="rect">
-            <a:avLst/>
-          </a:prstGeom>
-          <a:noFill/>
-          <a:ln/>
-        </p:spPr>
-        <p:txBody>
-          <a:bodyPr wrap="square" lIns="0" tIns="0" rIns="0" bIns="0" rtlCol="0" anchor="ctr"/>
-          <a:lstStyle/>
-          <a:p>
-            <a:pPr rtl="1" algn="ctr" indent="0" marL="0">
-              <a:buNone/>
-            </a:pPr>
-            <a:r>
-              <a:rPr lang="en-US" sz="3000" b="1" dirty="0">
-                <a:solidFill>
-                  <a:srgbClr val="E8862E"/>
-                </a:solidFill>
-                <a:latin typeface="Arial" pitchFamily="34" charset="0"/>
-                <a:ea typeface="Arial" pitchFamily="34" charset="-122"/>
-                <a:cs typeface="Arial" pitchFamily="34" charset="-120"/>
-              </a:rPr>
-              <a:t>אפס</a:t>
-            </a:r>
-            <a:endParaRPr lang="en-US" sz="3000" dirty="0"/>
-          </a:p>
-        </p:txBody>
-      </p:sp>
-      <p:sp>
-        <p:nvSpPr>
-          <p:cNvPr id="23" name="Text 21"/>
-          <p:cNvSpPr/>
-          <p:nvPr/>
-        </p:nvSpPr>
-        <p:spPr>
-          <a:xfrm>
-            <a:off x="649224" y="4343400"/>
-            <a:ext cx="2395728" cy="320040"/>
-          </a:xfrm>
-          <a:prstGeom prst="rect">
-            <a:avLst/>
-          </a:prstGeom>
-          <a:noFill/>
-          <a:ln/>
-        </p:spPr>
-        <p:txBody>
-          <a:bodyPr wrap="square" lIns="0" tIns="0" rIns="0" bIns="0" rtlCol="0" anchor="ctr"/>
-          <a:lstStyle/>
-          <a:p>
-            <a:pPr rtl="1" algn="ctr" indent="0" marL="0">
-              <a:buNone/>
-            </a:pPr>
-            <a:r>
-              <a:rPr lang="en-US" sz="1100" dirty="0">
-                <a:solidFill>
-                  <a:srgbClr val="5B6B68"/>
-                </a:solidFill>
-                <a:latin typeface="Arial" pitchFamily="34" charset="0"/>
-                <a:ea typeface="Arial" pitchFamily="34" charset="-122"/>
-                <a:cs typeface="Arial" pitchFamily="34" charset="-120"/>
-              </a:rPr>
-              <a:t>היעד לאחר המערכת</a:t>
-            </a:r>
-            <a:endParaRPr lang="en-US" sz="1100" dirty="0"/>
-          </a:p>
-        </p:txBody>
-      </p:sp>
-      <p:sp>
-        <p:nvSpPr>
-          <p:cNvPr id="24" name="Text 22"/>
-          <p:cNvSpPr/>
-          <p:nvPr/>
-        </p:nvSpPr>
-        <p:spPr>
-          <a:xfrm>
-            <a:off x="502920" y="5257800"/>
-            <a:ext cx="11183112" cy="457200"/>
+              <a:t>מטרת הפרויקט: ניתוח, איפיון ועיצוב של מערכת מידע מרכזית אחת שתנהל את מחזור הטיפול המלא בבקשת לקוח, מקליטת הפנייה ועד החשבונית והשכר, ותספק להנהלה תמונת מצב שוטפת.</a:t>
+            </a:r>
+            <a:endParaRPr lang="en-US" sz="1600" dirty="0"/>
+          </a:p>
+        </p:txBody>
+      </p:sp>
+      <p:graphicFrame>
+        <p:nvGraphicFramePr>
+          <p:cNvPr id="5" name="Table 0"/>
+          <p:cNvGraphicFramePr>
+            <a:graphicFrameLocks noGrp="1"/>
+          </p:cNvGraphicFramePr>
+          <p:nvPr>
+            <p:extLst>
+              <p:ext uri="{D42A27DB-BD31-4B8C-83A1-F6EECF244321}">
+                <p14:modId xmlns:p14="http://schemas.microsoft.com/office/powerpoint/2010/main" val="1579011935"/>
+              </p:ext>
+            </p:extLst>
+          </p:nvPr>
+        </p:nvGraphicFramePr>
+        <p:xfrm>
+          <a:off x="1188720" y="2011680"/>
+          <a:ext cx="9811512" cy="914400"/>
+        </p:xfrm>
+        <a:graphic>
+          <a:graphicData uri="http://schemas.openxmlformats.org/drawingml/2006/table">
+            <a:tbl>
+              <a:tblPr/>
+              <a:tblGrid>
+                <a:gridCol w="3200400"/>
+                <a:gridCol w="3291840"/>
+                <a:gridCol w="3319272"/>
+              </a:tblGrid>
+              <a:tr h="530352">
+                <a:tc>
+                  <a:txBody>
+                    <a:bodyPr/>
+                    <a:lstStyle/>
+                    <a:p>
+                      <a:pPr algn="ctr" indent="0" marL="0">
+                        <a:buNone/>
+                      </a:pPr>
+                      <a:r>
+                        <a:rPr lang="en-US" sz="1400" b="1" dirty="0">
+                          <a:solidFill>
+                            <a:srgbClr val="FFFFFF"/>
+                          </a:solidFill>
+                          <a:latin typeface="Arial" pitchFamily="34" charset="0"/>
+                          <a:ea typeface="Arial" pitchFamily="34" charset="-122"/>
+                          <a:cs typeface="Arial" pitchFamily="34" charset="-120"/>
+                        </a:rPr>
+                        <a:t>היעד לאחר המערכת</a:t>
+                      </a:r>
+                      <a:endParaRPr lang="en-US" sz="1400" dirty="0">
+                        <a:latin typeface="Arial" charset="0"/>
+                        <a:ea typeface="Arial" charset="0"/>
+                        <a:cs typeface="Arial" charset="0"/>
+                      </a:endParaRPr>
+                    </a:p>
+                  </a:txBody>
+                  <a:tcPr marL="54864" marR="54864" marT="54864" marB="54864" anchor="ctr">
+                    <a:lnL w="9525" cap="flat" cmpd="sng" algn="ctr">
+                      <a:solidFill>
+                        <a:srgbClr val="D5E3DF"/>
+                      </a:solidFill>
+                      <a:prstDash val="solid"/>
+                      <a:round/>
+                      <a:headEnd type="none" w="med" len="med"/>
+                      <a:tailEnd type="none" w="med" len="med"/>
+                    </a:lnL>
+                    <a:lnR w="9525" cap="flat" cmpd="sng" algn="ctr">
+                      <a:solidFill>
+                        <a:srgbClr val="D5E3DF"/>
+                      </a:solidFill>
+                      <a:prstDash val="solid"/>
+                      <a:round/>
+                      <a:headEnd type="none" w="med" len="med"/>
+                      <a:tailEnd type="none" w="med" len="med"/>
+                    </a:lnR>
+                    <a:lnT w="9525" cap="flat" cmpd="sng" algn="ctr">
+                      <a:solidFill>
+                        <a:srgbClr val="D5E3DF"/>
+                      </a:solidFill>
+                      <a:prstDash val="solid"/>
+                      <a:round/>
+                      <a:headEnd type="none" w="med" len="med"/>
+                      <a:tailEnd type="none" w="med" len="med"/>
+                    </a:lnT>
+                    <a:lnB w="9525" cap="flat" cmpd="sng" algn="ctr">
+                      <a:solidFill>
+                        <a:srgbClr val="D5E3DF"/>
+                      </a:solidFill>
+                      <a:prstDash val="solid"/>
+                      <a:round/>
+                      <a:headEnd type="none" w="med" len="med"/>
+                      <a:tailEnd type="none" w="med" len="med"/>
+                    </a:lnB>
+                    <a:solidFill>
+                      <a:srgbClr val="0F4C46"/>
+                    </a:solidFill>
+                  </a:tcPr>
+                </a:tc>
+                <a:tc>
+                  <a:txBody>
+                    <a:bodyPr/>
+                    <a:lstStyle/>
+                    <a:p>
+                      <a:pPr algn="ctr" indent="0" marL="0">
+                        <a:buNone/>
+                      </a:pPr>
+                      <a:r>
+                        <a:rPr lang="en-US" sz="1400" b="1" dirty="0">
+                          <a:solidFill>
+                            <a:srgbClr val="FFFFFF"/>
+                          </a:solidFill>
+                          <a:latin typeface="Arial" pitchFamily="34" charset="0"/>
+                          <a:ea typeface="Arial" pitchFamily="34" charset="-122"/>
+                          <a:cs typeface="Arial" pitchFamily="34" charset="-120"/>
+                        </a:rPr>
+                        <a:t>המצב הקיים</a:t>
+                      </a:r>
+                      <a:endParaRPr lang="en-US" sz="1400" dirty="0">
+                        <a:latin typeface="Arial" charset="0"/>
+                        <a:ea typeface="Arial" charset="0"/>
+                        <a:cs typeface="Arial" charset="0"/>
+                      </a:endParaRPr>
+                    </a:p>
+                  </a:txBody>
+                  <a:tcPr marL="54864" marR="54864" marT="54864" marB="54864" anchor="ctr">
+                    <a:lnL w="9525" cap="flat" cmpd="sng" algn="ctr">
+                      <a:solidFill>
+                        <a:srgbClr val="D5E3DF"/>
+                      </a:solidFill>
+                      <a:prstDash val="solid"/>
+                      <a:round/>
+                      <a:headEnd type="none" w="med" len="med"/>
+                      <a:tailEnd type="none" w="med" len="med"/>
+                    </a:lnL>
+                    <a:lnR w="9525" cap="flat" cmpd="sng" algn="ctr">
+                      <a:solidFill>
+                        <a:srgbClr val="D5E3DF"/>
+                      </a:solidFill>
+                      <a:prstDash val="solid"/>
+                      <a:round/>
+                      <a:headEnd type="none" w="med" len="med"/>
+                      <a:tailEnd type="none" w="med" len="med"/>
+                    </a:lnR>
+                    <a:lnT w="9525" cap="flat" cmpd="sng" algn="ctr">
+                      <a:solidFill>
+                        <a:srgbClr val="D5E3DF"/>
+                      </a:solidFill>
+                      <a:prstDash val="solid"/>
+                      <a:round/>
+                      <a:headEnd type="none" w="med" len="med"/>
+                      <a:tailEnd type="none" w="med" len="med"/>
+                    </a:lnT>
+                    <a:lnB w="9525" cap="flat" cmpd="sng" algn="ctr">
+                      <a:solidFill>
+                        <a:srgbClr val="D5E3DF"/>
+                      </a:solidFill>
+                      <a:prstDash val="solid"/>
+                      <a:round/>
+                      <a:headEnd type="none" w="med" len="med"/>
+                      <a:tailEnd type="none" w="med" len="med"/>
+                    </a:lnB>
+                    <a:solidFill>
+                      <a:srgbClr val="0F4C46"/>
+                    </a:solidFill>
+                  </a:tcPr>
+                </a:tc>
+                <a:tc>
+                  <a:txBody>
+                    <a:bodyPr/>
+                    <a:lstStyle/>
+                    <a:p>
+                      <a:pPr algn="ctr" indent="0" marL="0">
+                        <a:buNone/>
+                      </a:pPr>
+                      <a:r>
+                        <a:rPr lang="en-US" sz="1400" b="1" dirty="0">
+                          <a:solidFill>
+                            <a:srgbClr val="FFFFFF"/>
+                          </a:solidFill>
+                          <a:latin typeface="Arial" pitchFamily="34" charset="0"/>
+                          <a:ea typeface="Arial" pitchFamily="34" charset="-122"/>
+                          <a:cs typeface="Arial" pitchFamily="34" charset="-120"/>
+                        </a:rPr>
+                        <a:t>המדד</a:t>
+                      </a:r>
+                      <a:endParaRPr lang="en-US" sz="1400" dirty="0">
+                        <a:latin typeface="Arial" charset="0"/>
+                        <a:ea typeface="Arial" charset="0"/>
+                        <a:cs typeface="Arial" charset="0"/>
+                      </a:endParaRPr>
+                    </a:p>
+                  </a:txBody>
+                  <a:tcPr marL="54864" marR="54864" marT="54864" marB="54864" anchor="ctr">
+                    <a:lnL w="9525" cap="flat" cmpd="sng" algn="ctr">
+                      <a:solidFill>
+                        <a:srgbClr val="D5E3DF"/>
+                      </a:solidFill>
+                      <a:prstDash val="solid"/>
+                      <a:round/>
+                      <a:headEnd type="none" w="med" len="med"/>
+                      <a:tailEnd type="none" w="med" len="med"/>
+                    </a:lnL>
+                    <a:lnR w="9525" cap="flat" cmpd="sng" algn="ctr">
+                      <a:solidFill>
+                        <a:srgbClr val="D5E3DF"/>
+                      </a:solidFill>
+                      <a:prstDash val="solid"/>
+                      <a:round/>
+                      <a:headEnd type="none" w="med" len="med"/>
+                      <a:tailEnd type="none" w="med" len="med"/>
+                    </a:lnR>
+                    <a:lnT w="9525" cap="flat" cmpd="sng" algn="ctr">
+                      <a:solidFill>
+                        <a:srgbClr val="D5E3DF"/>
+                      </a:solidFill>
+                      <a:prstDash val="solid"/>
+                      <a:round/>
+                      <a:headEnd type="none" w="med" len="med"/>
+                      <a:tailEnd type="none" w="med" len="med"/>
+                    </a:lnT>
+                    <a:lnB w="9525" cap="flat" cmpd="sng" algn="ctr">
+                      <a:solidFill>
+                        <a:srgbClr val="D5E3DF"/>
+                      </a:solidFill>
+                      <a:prstDash val="solid"/>
+                      <a:round/>
+                      <a:headEnd type="none" w="med" len="med"/>
+                      <a:tailEnd type="none" w="med" len="med"/>
+                    </a:lnB>
+                    <a:solidFill>
+                      <a:srgbClr val="0F4C46"/>
+                    </a:solidFill>
+                  </a:tcPr>
+                </a:tc>
+              </a:tr>
+              <a:tr h="530352">
+                <a:tc>
+                  <a:txBody>
+                    <a:bodyPr/>
+                    <a:lstStyle/>
+                    <a:p>
+                      <a:pPr algn="ctr" indent="0" marL="0">
+                        <a:buNone/>
+                      </a:pPr>
+                      <a:r>
+                        <a:rPr lang="en-US" sz="1300" b="1" dirty="0">
+                          <a:solidFill>
+                            <a:srgbClr val="0F4C46"/>
+                          </a:solidFill>
+                          <a:latin typeface="Arial" pitchFamily="34" charset="0"/>
+                          <a:ea typeface="Arial" pitchFamily="34" charset="-122"/>
+                          <a:cs typeface="Arial" pitchFamily="34" charset="-120"/>
+                        </a:rPr>
+                        <a:t>5 דקות</a:t>
+                      </a:r>
+                      <a:endParaRPr lang="en-US" sz="1300" dirty="0">
+                        <a:latin typeface="Arial" charset="0"/>
+                        <a:ea typeface="Arial" charset="0"/>
+                        <a:cs typeface="Arial" charset="0"/>
+                      </a:endParaRPr>
+                    </a:p>
+                  </a:txBody>
+                  <a:tcPr marL="54864" marR="54864" marT="54864" marB="54864" anchor="ctr">
+                    <a:lnL w="9525" cap="flat" cmpd="sng" algn="ctr">
+                      <a:solidFill>
+                        <a:srgbClr val="D5E3DF"/>
+                      </a:solidFill>
+                      <a:prstDash val="solid"/>
+                      <a:round/>
+                      <a:headEnd type="none" w="med" len="med"/>
+                      <a:tailEnd type="none" w="med" len="med"/>
+                    </a:lnL>
+                    <a:lnR w="9525" cap="flat" cmpd="sng" algn="ctr">
+                      <a:solidFill>
+                        <a:srgbClr val="D5E3DF"/>
+                      </a:solidFill>
+                      <a:prstDash val="solid"/>
+                      <a:round/>
+                      <a:headEnd type="none" w="med" len="med"/>
+                      <a:tailEnd type="none" w="med" len="med"/>
+                    </a:lnR>
+                    <a:lnT w="9525" cap="flat" cmpd="sng" algn="ctr">
+                      <a:solidFill>
+                        <a:srgbClr val="D5E3DF"/>
+                      </a:solidFill>
+                      <a:prstDash val="solid"/>
+                      <a:round/>
+                      <a:headEnd type="none" w="med" len="med"/>
+                      <a:tailEnd type="none" w="med" len="med"/>
+                    </a:lnT>
+                    <a:lnB w="9525" cap="flat" cmpd="sng" algn="ctr">
+                      <a:solidFill>
+                        <a:srgbClr val="D5E3DF"/>
+                      </a:solidFill>
+                      <a:prstDash val="solid"/>
+                      <a:round/>
+                      <a:headEnd type="none" w="med" len="med"/>
+                      <a:tailEnd type="none" w="med" len="med"/>
+                    </a:lnB>
+                    <a:solidFill>
+                      <a:srgbClr val="F4FAF8"/>
+                    </a:solidFill>
+                  </a:tcPr>
+                </a:tc>
+                <a:tc>
+                  <a:txBody>
+                    <a:bodyPr/>
+                    <a:lstStyle/>
+                    <a:p>
+                      <a:pPr algn="ctr" indent="0" marL="0">
+                        <a:buNone/>
+                      </a:pPr>
+                      <a:r>
+                        <a:rPr lang="en-US" sz="1300" dirty="0">
+                          <a:solidFill>
+                            <a:srgbClr val="1F2937"/>
+                          </a:solidFill>
+                          <a:latin typeface="Arial" pitchFamily="34" charset="0"/>
+                          <a:ea typeface="Arial" pitchFamily="34" charset="-122"/>
+                          <a:cs typeface="Arial" pitchFamily="34" charset="-120"/>
+                        </a:rPr>
+                        <a:t>כ-20 דקות בממוצע</a:t>
+                      </a:r>
+                      <a:endParaRPr lang="en-US" sz="1300" dirty="0">
+                        <a:latin typeface="Arial" charset="0"/>
+                        <a:ea typeface="Arial" charset="0"/>
+                        <a:cs typeface="Arial" charset="0"/>
+                      </a:endParaRPr>
+                    </a:p>
+                  </a:txBody>
+                  <a:tcPr marL="54864" marR="54864" marT="54864" marB="54864" anchor="ctr">
+                    <a:lnL w="9525" cap="flat" cmpd="sng" algn="ctr">
+                      <a:solidFill>
+                        <a:srgbClr val="D5E3DF"/>
+                      </a:solidFill>
+                      <a:prstDash val="solid"/>
+                      <a:round/>
+                      <a:headEnd type="none" w="med" len="med"/>
+                      <a:tailEnd type="none" w="med" len="med"/>
+                    </a:lnL>
+                    <a:lnR w="9525" cap="flat" cmpd="sng" algn="ctr">
+                      <a:solidFill>
+                        <a:srgbClr val="D5E3DF"/>
+                      </a:solidFill>
+                      <a:prstDash val="solid"/>
+                      <a:round/>
+                      <a:headEnd type="none" w="med" len="med"/>
+                      <a:tailEnd type="none" w="med" len="med"/>
+                    </a:lnR>
+                    <a:lnT w="9525" cap="flat" cmpd="sng" algn="ctr">
+                      <a:solidFill>
+                        <a:srgbClr val="D5E3DF"/>
+                      </a:solidFill>
+                      <a:prstDash val="solid"/>
+                      <a:round/>
+                      <a:headEnd type="none" w="med" len="med"/>
+                      <a:tailEnd type="none" w="med" len="med"/>
+                    </a:lnT>
+                    <a:lnB w="9525" cap="flat" cmpd="sng" algn="ctr">
+                      <a:solidFill>
+                        <a:srgbClr val="D5E3DF"/>
+                      </a:solidFill>
+                      <a:prstDash val="solid"/>
+                      <a:round/>
+                      <a:headEnd type="none" w="med" len="med"/>
+                      <a:tailEnd type="none" w="med" len="med"/>
+                    </a:lnB>
+                    <a:solidFill>
+                      <a:srgbClr val="F4FAF8"/>
+                    </a:solidFill>
+                  </a:tcPr>
+                </a:tc>
+                <a:tc>
+                  <a:txBody>
+                    <a:bodyPr/>
+                    <a:lstStyle/>
+                    <a:p>
+                      <a:pPr algn="r" indent="0" marL="0">
+                        <a:buNone/>
+                      </a:pPr>
+                      <a:r>
+                        <a:rPr lang="en-US" sz="1300" b="1" dirty="0">
+                          <a:solidFill>
+                            <a:srgbClr val="1F2937"/>
+                          </a:solidFill>
+                          <a:latin typeface="Arial" pitchFamily="34" charset="0"/>
+                          <a:ea typeface="Arial" pitchFamily="34" charset="-122"/>
+                          <a:cs typeface="Arial" pitchFamily="34" charset="-120"/>
+                        </a:rPr>
+                        <a:t>זמן קליטת בקשה חדשה</a:t>
+                      </a:r>
+                      <a:endParaRPr lang="en-US" sz="1300" dirty="0">
+                        <a:latin typeface="Arial" charset="0"/>
+                        <a:ea typeface="Arial" charset="0"/>
+                        <a:cs typeface="Arial" charset="0"/>
+                      </a:endParaRPr>
+                    </a:p>
+                  </a:txBody>
+                  <a:tcPr marL="54864" marR="54864" marT="54864" marB="54864" anchor="ctr">
+                    <a:lnL w="9525" cap="flat" cmpd="sng" algn="ctr">
+                      <a:solidFill>
+                        <a:srgbClr val="D5E3DF"/>
+                      </a:solidFill>
+                      <a:prstDash val="solid"/>
+                      <a:round/>
+                      <a:headEnd type="none" w="med" len="med"/>
+                      <a:tailEnd type="none" w="med" len="med"/>
+                    </a:lnL>
+                    <a:lnR w="9525" cap="flat" cmpd="sng" algn="ctr">
+                      <a:solidFill>
+                        <a:srgbClr val="D5E3DF"/>
+                      </a:solidFill>
+                      <a:prstDash val="solid"/>
+                      <a:round/>
+                      <a:headEnd type="none" w="med" len="med"/>
+                      <a:tailEnd type="none" w="med" len="med"/>
+                    </a:lnR>
+                    <a:lnT w="9525" cap="flat" cmpd="sng" algn="ctr">
+                      <a:solidFill>
+                        <a:srgbClr val="D5E3DF"/>
+                      </a:solidFill>
+                      <a:prstDash val="solid"/>
+                      <a:round/>
+                      <a:headEnd type="none" w="med" len="med"/>
+                      <a:tailEnd type="none" w="med" len="med"/>
+                    </a:lnT>
+                    <a:lnB w="9525" cap="flat" cmpd="sng" algn="ctr">
+                      <a:solidFill>
+                        <a:srgbClr val="D5E3DF"/>
+                      </a:solidFill>
+                      <a:prstDash val="solid"/>
+                      <a:round/>
+                      <a:headEnd type="none" w="med" len="med"/>
+                      <a:tailEnd type="none" w="med" len="med"/>
+                    </a:lnB>
+                    <a:solidFill>
+                      <a:srgbClr val="F4FAF8"/>
+                    </a:solidFill>
+                  </a:tcPr>
+                </a:tc>
+              </a:tr>
+              <a:tr h="530352">
+                <a:tc>
+                  <a:txBody>
+                    <a:bodyPr/>
+                    <a:lstStyle/>
+                    <a:p>
+                      <a:pPr algn="ctr" indent="0" marL="0">
+                        <a:buNone/>
+                      </a:pPr>
+                      <a:r>
+                        <a:rPr lang="en-US" sz="1300" b="1" dirty="0">
+                          <a:solidFill>
+                            <a:srgbClr val="0F4C46"/>
+                          </a:solidFill>
+                          <a:latin typeface="Arial" pitchFamily="34" charset="0"/>
+                          <a:ea typeface="Arial" pitchFamily="34" charset="-122"/>
+                          <a:cs typeface="Arial" pitchFamily="34" charset="-120"/>
+                        </a:rPr>
+                        <a:t>יום עבודה אחד</a:t>
+                      </a:r>
+                      <a:endParaRPr lang="en-US" sz="1300" dirty="0">
+                        <a:latin typeface="Arial" charset="0"/>
+                        <a:ea typeface="Arial" charset="0"/>
+                        <a:cs typeface="Arial" charset="0"/>
+                      </a:endParaRPr>
+                    </a:p>
+                  </a:txBody>
+                  <a:tcPr marL="54864" marR="54864" marT="54864" marB="54864" anchor="ctr">
+                    <a:lnL w="9525" cap="flat" cmpd="sng" algn="ctr">
+                      <a:solidFill>
+                        <a:srgbClr val="D5E3DF"/>
+                      </a:solidFill>
+                      <a:prstDash val="solid"/>
+                      <a:round/>
+                      <a:headEnd type="none" w="med" len="med"/>
+                      <a:tailEnd type="none" w="med" len="med"/>
+                    </a:lnL>
+                    <a:lnR w="9525" cap="flat" cmpd="sng" algn="ctr">
+                      <a:solidFill>
+                        <a:srgbClr val="D5E3DF"/>
+                      </a:solidFill>
+                      <a:prstDash val="solid"/>
+                      <a:round/>
+                      <a:headEnd type="none" w="med" len="med"/>
+                      <a:tailEnd type="none" w="med" len="med"/>
+                    </a:lnR>
+                    <a:lnT w="9525" cap="flat" cmpd="sng" algn="ctr">
+                      <a:solidFill>
+                        <a:srgbClr val="D5E3DF"/>
+                      </a:solidFill>
+                      <a:prstDash val="solid"/>
+                      <a:round/>
+                      <a:headEnd type="none" w="med" len="med"/>
+                      <a:tailEnd type="none" w="med" len="med"/>
+                    </a:lnT>
+                    <a:lnB w="9525" cap="flat" cmpd="sng" algn="ctr">
+                      <a:solidFill>
+                        <a:srgbClr val="D5E3DF"/>
+                      </a:solidFill>
+                      <a:prstDash val="solid"/>
+                      <a:round/>
+                      <a:headEnd type="none" w="med" len="med"/>
+                      <a:tailEnd type="none" w="med" len="med"/>
+                    </a:lnB>
+                    <a:solidFill>
+                      <a:srgbClr val="FFFFFF"/>
+                    </a:solidFill>
+                  </a:tcPr>
+                </a:tc>
+                <a:tc>
+                  <a:txBody>
+                    <a:bodyPr/>
+                    <a:lstStyle/>
+                    <a:p>
+                      <a:pPr algn="ctr" indent="0" marL="0">
+                        <a:buNone/>
+                      </a:pPr>
+                      <a:r>
+                        <a:rPr lang="en-US" sz="1300" dirty="0">
+                          <a:solidFill>
+                            <a:srgbClr val="1F2937"/>
+                          </a:solidFill>
+                          <a:latin typeface="Arial" pitchFamily="34" charset="0"/>
+                          <a:ea typeface="Arial" pitchFamily="34" charset="-122"/>
+                          <a:cs typeface="Arial" pitchFamily="34" charset="-120"/>
+                        </a:rPr>
+                        <a:t>2-3 ימי עבודה</a:t>
+                      </a:r>
+                      <a:endParaRPr lang="en-US" sz="1300" dirty="0">
+                        <a:latin typeface="Arial" charset="0"/>
+                        <a:ea typeface="Arial" charset="0"/>
+                        <a:cs typeface="Arial" charset="0"/>
+                      </a:endParaRPr>
+                    </a:p>
+                  </a:txBody>
+                  <a:tcPr marL="54864" marR="54864" marT="54864" marB="54864" anchor="ctr">
+                    <a:lnL w="9525" cap="flat" cmpd="sng" algn="ctr">
+                      <a:solidFill>
+                        <a:srgbClr val="D5E3DF"/>
+                      </a:solidFill>
+                      <a:prstDash val="solid"/>
+                      <a:round/>
+                      <a:headEnd type="none" w="med" len="med"/>
+                      <a:tailEnd type="none" w="med" len="med"/>
+                    </a:lnL>
+                    <a:lnR w="9525" cap="flat" cmpd="sng" algn="ctr">
+                      <a:solidFill>
+                        <a:srgbClr val="D5E3DF"/>
+                      </a:solidFill>
+                      <a:prstDash val="solid"/>
+                      <a:round/>
+                      <a:headEnd type="none" w="med" len="med"/>
+                      <a:tailEnd type="none" w="med" len="med"/>
+                    </a:lnR>
+                    <a:lnT w="9525" cap="flat" cmpd="sng" algn="ctr">
+                      <a:solidFill>
+                        <a:srgbClr val="D5E3DF"/>
+                      </a:solidFill>
+                      <a:prstDash val="solid"/>
+                      <a:round/>
+                      <a:headEnd type="none" w="med" len="med"/>
+                      <a:tailEnd type="none" w="med" len="med"/>
+                    </a:lnT>
+                    <a:lnB w="9525" cap="flat" cmpd="sng" algn="ctr">
+                      <a:solidFill>
+                        <a:srgbClr val="D5E3DF"/>
+                      </a:solidFill>
+                      <a:prstDash val="solid"/>
+                      <a:round/>
+                      <a:headEnd type="none" w="med" len="med"/>
+                      <a:tailEnd type="none" w="med" len="med"/>
+                    </a:lnB>
+                    <a:solidFill>
+                      <a:srgbClr val="FFFFFF"/>
+                    </a:solidFill>
+                  </a:tcPr>
+                </a:tc>
+                <a:tc>
+                  <a:txBody>
+                    <a:bodyPr/>
+                    <a:lstStyle/>
+                    <a:p>
+                      <a:pPr algn="r" indent="0" marL="0">
+                        <a:buNone/>
+                      </a:pPr>
+                      <a:r>
+                        <a:rPr lang="en-US" sz="1300" b="1" dirty="0">
+                          <a:solidFill>
+                            <a:srgbClr val="1F2937"/>
+                          </a:solidFill>
+                          <a:latin typeface="Arial" pitchFamily="34" charset="0"/>
+                          <a:ea typeface="Arial" pitchFamily="34" charset="-122"/>
+                          <a:cs typeface="Arial" pitchFamily="34" charset="-120"/>
+                        </a:rPr>
+                        <a:t>זמן הכנת הצעת מחיר</a:t>
+                      </a:r>
+                      <a:endParaRPr lang="en-US" sz="1300" dirty="0">
+                        <a:latin typeface="Arial" charset="0"/>
+                        <a:ea typeface="Arial" charset="0"/>
+                        <a:cs typeface="Arial" charset="0"/>
+                      </a:endParaRPr>
+                    </a:p>
+                  </a:txBody>
+                  <a:tcPr marL="54864" marR="54864" marT="54864" marB="54864" anchor="ctr">
+                    <a:lnL w="9525" cap="flat" cmpd="sng" algn="ctr">
+                      <a:solidFill>
+                        <a:srgbClr val="D5E3DF"/>
+                      </a:solidFill>
+                      <a:prstDash val="solid"/>
+                      <a:round/>
+                      <a:headEnd type="none" w="med" len="med"/>
+                      <a:tailEnd type="none" w="med" len="med"/>
+                    </a:lnL>
+                    <a:lnR w="9525" cap="flat" cmpd="sng" algn="ctr">
+                      <a:solidFill>
+                        <a:srgbClr val="D5E3DF"/>
+                      </a:solidFill>
+                      <a:prstDash val="solid"/>
+                      <a:round/>
+                      <a:headEnd type="none" w="med" len="med"/>
+                      <a:tailEnd type="none" w="med" len="med"/>
+                    </a:lnR>
+                    <a:lnT w="9525" cap="flat" cmpd="sng" algn="ctr">
+                      <a:solidFill>
+                        <a:srgbClr val="D5E3DF"/>
+                      </a:solidFill>
+                      <a:prstDash val="solid"/>
+                      <a:round/>
+                      <a:headEnd type="none" w="med" len="med"/>
+                      <a:tailEnd type="none" w="med" len="med"/>
+                    </a:lnT>
+                    <a:lnB w="9525" cap="flat" cmpd="sng" algn="ctr">
+                      <a:solidFill>
+                        <a:srgbClr val="D5E3DF"/>
+                      </a:solidFill>
+                      <a:prstDash val="solid"/>
+                      <a:round/>
+                      <a:headEnd type="none" w="med" len="med"/>
+                      <a:tailEnd type="none" w="med" len="med"/>
+                    </a:lnB>
+                    <a:solidFill>
+                      <a:srgbClr val="FFFFFF"/>
+                    </a:solidFill>
+                  </a:tcPr>
+                </a:tc>
+              </a:tr>
+              <a:tr h="530352">
+                <a:tc>
+                  <a:txBody>
+                    <a:bodyPr/>
+                    <a:lstStyle/>
+                    <a:p>
+                      <a:pPr algn="ctr" indent="0" marL="0">
+                        <a:buNone/>
+                      </a:pPr>
+                      <a:r>
+                        <a:rPr lang="en-US" sz="1300" b="1" dirty="0">
+                          <a:solidFill>
+                            <a:srgbClr val="0F4C46"/>
+                          </a:solidFill>
+                          <a:latin typeface="Arial" pitchFamily="34" charset="0"/>
+                          <a:ea typeface="Arial" pitchFamily="34" charset="-122"/>
+                          <a:cs typeface="Arial" pitchFamily="34" charset="-120"/>
+                        </a:rPr>
+                        <a:t>אפס, רישום מרוכז אחד</a:t>
+                      </a:r>
+                      <a:endParaRPr lang="en-US" sz="1300" dirty="0">
+                        <a:latin typeface="Arial" charset="0"/>
+                        <a:ea typeface="Arial" charset="0"/>
+                        <a:cs typeface="Arial" charset="0"/>
+                      </a:endParaRPr>
+                    </a:p>
+                  </a:txBody>
+                  <a:tcPr marL="54864" marR="54864" marT="54864" marB="54864" anchor="ctr">
+                    <a:lnL w="9525" cap="flat" cmpd="sng" algn="ctr">
+                      <a:solidFill>
+                        <a:srgbClr val="D5E3DF"/>
+                      </a:solidFill>
+                      <a:prstDash val="solid"/>
+                      <a:round/>
+                      <a:headEnd type="none" w="med" len="med"/>
+                      <a:tailEnd type="none" w="med" len="med"/>
+                    </a:lnL>
+                    <a:lnR w="9525" cap="flat" cmpd="sng" algn="ctr">
+                      <a:solidFill>
+                        <a:srgbClr val="D5E3DF"/>
+                      </a:solidFill>
+                      <a:prstDash val="solid"/>
+                      <a:round/>
+                      <a:headEnd type="none" w="med" len="med"/>
+                      <a:tailEnd type="none" w="med" len="med"/>
+                    </a:lnR>
+                    <a:lnT w="9525" cap="flat" cmpd="sng" algn="ctr">
+                      <a:solidFill>
+                        <a:srgbClr val="D5E3DF"/>
+                      </a:solidFill>
+                      <a:prstDash val="solid"/>
+                      <a:round/>
+                      <a:headEnd type="none" w="med" len="med"/>
+                      <a:tailEnd type="none" w="med" len="med"/>
+                    </a:lnT>
+                    <a:lnB w="9525" cap="flat" cmpd="sng" algn="ctr">
+                      <a:solidFill>
+                        <a:srgbClr val="D5E3DF"/>
+                      </a:solidFill>
+                      <a:prstDash val="solid"/>
+                      <a:round/>
+                      <a:headEnd type="none" w="med" len="med"/>
+                      <a:tailEnd type="none" w="med" len="med"/>
+                    </a:lnB>
+                    <a:solidFill>
+                      <a:srgbClr val="F4FAF8"/>
+                    </a:solidFill>
+                  </a:tcPr>
+                </a:tc>
+                <a:tc>
+                  <a:txBody>
+                    <a:bodyPr/>
+                    <a:lstStyle/>
+                    <a:p>
+                      <a:pPr algn="ctr" indent="0" marL="0">
+                        <a:buNone/>
+                      </a:pPr>
+                      <a:r>
+                        <a:rPr lang="en-US" sz="1300" dirty="0">
+                          <a:solidFill>
+                            <a:srgbClr val="1F2937"/>
+                          </a:solidFill>
+                          <a:latin typeface="Arial" pitchFamily="34" charset="0"/>
+                          <a:ea typeface="Arial" pitchFamily="34" charset="-122"/>
+                          <a:cs typeface="Arial" pitchFamily="34" charset="-120"/>
+                        </a:rPr>
+                        <a:t>מספר מקרים בחודש</a:t>
+                      </a:r>
+                      <a:endParaRPr lang="en-US" sz="1300" dirty="0">
+                        <a:latin typeface="Arial" charset="0"/>
+                        <a:ea typeface="Arial" charset="0"/>
+                        <a:cs typeface="Arial" charset="0"/>
+                      </a:endParaRPr>
+                    </a:p>
+                  </a:txBody>
+                  <a:tcPr marL="54864" marR="54864" marT="54864" marB="54864" anchor="ctr">
+                    <a:lnL w="9525" cap="flat" cmpd="sng" algn="ctr">
+                      <a:solidFill>
+                        <a:srgbClr val="D5E3DF"/>
+                      </a:solidFill>
+                      <a:prstDash val="solid"/>
+                      <a:round/>
+                      <a:headEnd type="none" w="med" len="med"/>
+                      <a:tailEnd type="none" w="med" len="med"/>
+                    </a:lnL>
+                    <a:lnR w="9525" cap="flat" cmpd="sng" algn="ctr">
+                      <a:solidFill>
+                        <a:srgbClr val="D5E3DF"/>
+                      </a:solidFill>
+                      <a:prstDash val="solid"/>
+                      <a:round/>
+                      <a:headEnd type="none" w="med" len="med"/>
+                      <a:tailEnd type="none" w="med" len="med"/>
+                    </a:lnR>
+                    <a:lnT w="9525" cap="flat" cmpd="sng" algn="ctr">
+                      <a:solidFill>
+                        <a:srgbClr val="D5E3DF"/>
+                      </a:solidFill>
+                      <a:prstDash val="solid"/>
+                      <a:round/>
+                      <a:headEnd type="none" w="med" len="med"/>
+                      <a:tailEnd type="none" w="med" len="med"/>
+                    </a:lnT>
+                    <a:lnB w="9525" cap="flat" cmpd="sng" algn="ctr">
+                      <a:solidFill>
+                        <a:srgbClr val="D5E3DF"/>
+                      </a:solidFill>
+                      <a:prstDash val="solid"/>
+                      <a:round/>
+                      <a:headEnd type="none" w="med" len="med"/>
+                      <a:tailEnd type="none" w="med" len="med"/>
+                    </a:lnB>
+                    <a:solidFill>
+                      <a:srgbClr val="F4FAF8"/>
+                    </a:solidFill>
+                  </a:tcPr>
+                </a:tc>
+                <a:tc>
+                  <a:txBody>
+                    <a:bodyPr/>
+                    <a:lstStyle/>
+                    <a:p>
+                      <a:pPr algn="r" indent="0" marL="0">
+                        <a:buNone/>
+                      </a:pPr>
+                      <a:r>
+                        <a:rPr lang="en-US" sz="1300" b="1" dirty="0">
+                          <a:solidFill>
+                            <a:srgbClr val="1F2937"/>
+                          </a:solidFill>
+                          <a:latin typeface="Arial" pitchFamily="34" charset="0"/>
+                          <a:ea typeface="Arial" pitchFamily="34" charset="-122"/>
+                          <a:cs typeface="Arial" pitchFamily="34" charset="-120"/>
+                        </a:rPr>
+                        <a:t>אובדן או כפילות רישום</a:t>
+                      </a:r>
+                      <a:endParaRPr lang="en-US" sz="1300" dirty="0">
+                        <a:latin typeface="Arial" charset="0"/>
+                        <a:ea typeface="Arial" charset="0"/>
+                        <a:cs typeface="Arial" charset="0"/>
+                      </a:endParaRPr>
+                    </a:p>
+                  </a:txBody>
+                  <a:tcPr marL="54864" marR="54864" marT="54864" marB="54864" anchor="ctr">
+                    <a:lnL w="9525" cap="flat" cmpd="sng" algn="ctr">
+                      <a:solidFill>
+                        <a:srgbClr val="D5E3DF"/>
+                      </a:solidFill>
+                      <a:prstDash val="solid"/>
+                      <a:round/>
+                      <a:headEnd type="none" w="med" len="med"/>
+                      <a:tailEnd type="none" w="med" len="med"/>
+                    </a:lnL>
+                    <a:lnR w="9525" cap="flat" cmpd="sng" algn="ctr">
+                      <a:solidFill>
+                        <a:srgbClr val="D5E3DF"/>
+                      </a:solidFill>
+                      <a:prstDash val="solid"/>
+                      <a:round/>
+                      <a:headEnd type="none" w="med" len="med"/>
+                      <a:tailEnd type="none" w="med" len="med"/>
+                    </a:lnR>
+                    <a:lnT w="9525" cap="flat" cmpd="sng" algn="ctr">
+                      <a:solidFill>
+                        <a:srgbClr val="D5E3DF"/>
+                      </a:solidFill>
+                      <a:prstDash val="solid"/>
+                      <a:round/>
+                      <a:headEnd type="none" w="med" len="med"/>
+                      <a:tailEnd type="none" w="med" len="med"/>
+                    </a:lnT>
+                    <a:lnB w="9525" cap="flat" cmpd="sng" algn="ctr">
+                      <a:solidFill>
+                        <a:srgbClr val="D5E3DF"/>
+                      </a:solidFill>
+                      <a:prstDash val="solid"/>
+                      <a:round/>
+                      <a:headEnd type="none" w="med" len="med"/>
+                      <a:tailEnd type="none" w="med" len="med"/>
+                    </a:lnB>
+                    <a:solidFill>
+                      <a:srgbClr val="F4FAF8"/>
+                    </a:solidFill>
+                  </a:tcPr>
+                </a:tc>
+              </a:tr>
+              <a:tr h="530352">
+                <a:tc>
+                  <a:txBody>
+                    <a:bodyPr/>
+                    <a:lstStyle/>
+                    <a:p>
+                      <a:pPr algn="ctr" indent="0" marL="0">
+                        <a:buNone/>
+                      </a:pPr>
+                      <a:r>
+                        <a:rPr lang="en-US" sz="1300" b="1" dirty="0">
+                          <a:solidFill>
+                            <a:srgbClr val="0F4C46"/>
+                          </a:solidFill>
+                          <a:latin typeface="Arial" pitchFamily="34" charset="0"/>
+                          <a:ea typeface="Arial" pitchFamily="34" charset="-122"/>
+                          <a:cs typeface="Arial" pitchFamily="34" charset="-120"/>
+                        </a:rPr>
+                        <a:t>עדכון מיידי במערכת</a:t>
+                      </a:r>
+                      <a:endParaRPr lang="en-US" sz="1300" dirty="0">
+                        <a:latin typeface="Arial" charset="0"/>
+                        <a:ea typeface="Arial" charset="0"/>
+                        <a:cs typeface="Arial" charset="0"/>
+                      </a:endParaRPr>
+                    </a:p>
+                  </a:txBody>
+                  <a:tcPr marL="54864" marR="54864" marT="54864" marB="54864" anchor="ctr">
+                    <a:lnL w="9525" cap="flat" cmpd="sng" algn="ctr">
+                      <a:solidFill>
+                        <a:srgbClr val="D5E3DF"/>
+                      </a:solidFill>
+                      <a:prstDash val="solid"/>
+                      <a:round/>
+                      <a:headEnd type="none" w="med" len="med"/>
+                      <a:tailEnd type="none" w="med" len="med"/>
+                    </a:lnL>
+                    <a:lnR w="9525" cap="flat" cmpd="sng" algn="ctr">
+                      <a:solidFill>
+                        <a:srgbClr val="D5E3DF"/>
+                      </a:solidFill>
+                      <a:prstDash val="solid"/>
+                      <a:round/>
+                      <a:headEnd type="none" w="med" len="med"/>
+                      <a:tailEnd type="none" w="med" len="med"/>
+                    </a:lnR>
+                    <a:lnT w="9525" cap="flat" cmpd="sng" algn="ctr">
+                      <a:solidFill>
+                        <a:srgbClr val="D5E3DF"/>
+                      </a:solidFill>
+                      <a:prstDash val="solid"/>
+                      <a:round/>
+                      <a:headEnd type="none" w="med" len="med"/>
+                      <a:tailEnd type="none" w="med" len="med"/>
+                    </a:lnT>
+                    <a:lnB w="9525" cap="flat" cmpd="sng" algn="ctr">
+                      <a:solidFill>
+                        <a:srgbClr val="D5E3DF"/>
+                      </a:solidFill>
+                      <a:prstDash val="solid"/>
+                      <a:round/>
+                      <a:headEnd type="none" w="med" len="med"/>
+                      <a:tailEnd type="none" w="med" len="med"/>
+                    </a:lnB>
+                    <a:solidFill>
+                      <a:srgbClr val="FFFFFF"/>
+                    </a:solidFill>
+                  </a:tcPr>
+                </a:tc>
+                <a:tc>
+                  <a:txBody>
+                    <a:bodyPr/>
+                    <a:lstStyle/>
+                    <a:p>
+                      <a:pPr algn="ctr" indent="0" marL="0">
+                        <a:buNone/>
+                      </a:pPr>
+                      <a:r>
+                        <a:rPr lang="en-US" sz="1300" dirty="0">
+                          <a:solidFill>
+                            <a:srgbClr val="1F2937"/>
+                          </a:solidFill>
+                          <a:latin typeface="Arial" pitchFamily="34" charset="0"/>
+                          <a:ea typeface="Arial" pitchFamily="34" charset="-122"/>
+                          <a:cs typeface="Arial" pitchFamily="34" charset="-120"/>
+                        </a:rPr>
+                        <a:t>סבב טלפונים, לעיתים באיחור</a:t>
+                      </a:r>
+                      <a:endParaRPr lang="en-US" sz="1300" dirty="0">
+                        <a:latin typeface="Arial" charset="0"/>
+                        <a:ea typeface="Arial" charset="0"/>
+                        <a:cs typeface="Arial" charset="0"/>
+                      </a:endParaRPr>
+                    </a:p>
+                  </a:txBody>
+                  <a:tcPr marL="54864" marR="54864" marT="54864" marB="54864" anchor="ctr">
+                    <a:lnL w="9525" cap="flat" cmpd="sng" algn="ctr">
+                      <a:solidFill>
+                        <a:srgbClr val="D5E3DF"/>
+                      </a:solidFill>
+                      <a:prstDash val="solid"/>
+                      <a:round/>
+                      <a:headEnd type="none" w="med" len="med"/>
+                      <a:tailEnd type="none" w="med" len="med"/>
+                    </a:lnL>
+                    <a:lnR w="9525" cap="flat" cmpd="sng" algn="ctr">
+                      <a:solidFill>
+                        <a:srgbClr val="D5E3DF"/>
+                      </a:solidFill>
+                      <a:prstDash val="solid"/>
+                      <a:round/>
+                      <a:headEnd type="none" w="med" len="med"/>
+                      <a:tailEnd type="none" w="med" len="med"/>
+                    </a:lnR>
+                    <a:lnT w="9525" cap="flat" cmpd="sng" algn="ctr">
+                      <a:solidFill>
+                        <a:srgbClr val="D5E3DF"/>
+                      </a:solidFill>
+                      <a:prstDash val="solid"/>
+                      <a:round/>
+                      <a:headEnd type="none" w="med" len="med"/>
+                      <a:tailEnd type="none" w="med" len="med"/>
+                    </a:lnT>
+                    <a:lnB w="9525" cap="flat" cmpd="sng" algn="ctr">
+                      <a:solidFill>
+                        <a:srgbClr val="D5E3DF"/>
+                      </a:solidFill>
+                      <a:prstDash val="solid"/>
+                      <a:round/>
+                      <a:headEnd type="none" w="med" len="med"/>
+                      <a:tailEnd type="none" w="med" len="med"/>
+                    </a:lnB>
+                    <a:solidFill>
+                      <a:srgbClr val="FFFFFF"/>
+                    </a:solidFill>
+                  </a:tcPr>
+                </a:tc>
+                <a:tc>
+                  <a:txBody>
+                    <a:bodyPr/>
+                    <a:lstStyle/>
+                    <a:p>
+                      <a:pPr algn="r" indent="0" marL="0">
+                        <a:buNone/>
+                      </a:pPr>
+                      <a:r>
+                        <a:rPr lang="en-US" sz="1300" b="1" dirty="0">
+                          <a:solidFill>
+                            <a:srgbClr val="1F2937"/>
+                          </a:solidFill>
+                          <a:latin typeface="Arial" pitchFamily="34" charset="0"/>
+                          <a:ea typeface="Arial" pitchFamily="34" charset="-122"/>
+                          <a:cs typeface="Arial" pitchFamily="34" charset="-120"/>
+                        </a:rPr>
+                        <a:t>עדכון עובד על שיבוץ</a:t>
+                      </a:r>
+                      <a:endParaRPr lang="en-US" sz="1300" dirty="0">
+                        <a:latin typeface="Arial" charset="0"/>
+                        <a:ea typeface="Arial" charset="0"/>
+                        <a:cs typeface="Arial" charset="0"/>
+                      </a:endParaRPr>
+                    </a:p>
+                  </a:txBody>
+                  <a:tcPr marL="54864" marR="54864" marT="54864" marB="54864" anchor="ctr">
+                    <a:lnL w="9525" cap="flat" cmpd="sng" algn="ctr">
+                      <a:solidFill>
+                        <a:srgbClr val="D5E3DF"/>
+                      </a:solidFill>
+                      <a:prstDash val="solid"/>
+                      <a:round/>
+                      <a:headEnd type="none" w="med" len="med"/>
+                      <a:tailEnd type="none" w="med" len="med"/>
+                    </a:lnL>
+                    <a:lnR w="9525" cap="flat" cmpd="sng" algn="ctr">
+                      <a:solidFill>
+                        <a:srgbClr val="D5E3DF"/>
+                      </a:solidFill>
+                      <a:prstDash val="solid"/>
+                      <a:round/>
+                      <a:headEnd type="none" w="med" len="med"/>
+                      <a:tailEnd type="none" w="med" len="med"/>
+                    </a:lnR>
+                    <a:lnT w="9525" cap="flat" cmpd="sng" algn="ctr">
+                      <a:solidFill>
+                        <a:srgbClr val="D5E3DF"/>
+                      </a:solidFill>
+                      <a:prstDash val="solid"/>
+                      <a:round/>
+                      <a:headEnd type="none" w="med" len="med"/>
+                      <a:tailEnd type="none" w="med" len="med"/>
+                    </a:lnT>
+                    <a:lnB w="9525" cap="flat" cmpd="sng" algn="ctr">
+                      <a:solidFill>
+                        <a:srgbClr val="D5E3DF"/>
+                      </a:solidFill>
+                      <a:prstDash val="solid"/>
+                      <a:round/>
+                      <a:headEnd type="none" w="med" len="med"/>
+                      <a:tailEnd type="none" w="med" len="med"/>
+                    </a:lnB>
+                    <a:solidFill>
+                      <a:srgbClr val="FFFFFF"/>
+                    </a:solidFill>
+                  </a:tcPr>
+                </a:tc>
+              </a:tr>
+              <a:tr h="530352">
+                <a:tc>
+                  <a:txBody>
+                    <a:bodyPr/>
+                    <a:lstStyle/>
+                    <a:p>
+                      <a:pPr algn="ctr" indent="0" marL="0">
+                        <a:buNone/>
+                      </a:pPr>
+                      <a:r>
+                        <a:rPr lang="en-US" sz="1300" b="1" dirty="0">
+                          <a:solidFill>
+                            <a:srgbClr val="0F4C46"/>
+                          </a:solidFill>
+                          <a:latin typeface="Arial" pitchFamily="34" charset="0"/>
+                          <a:ea typeface="Arial" pitchFamily="34" charset="-122"/>
+                          <a:cs typeface="Arial" pitchFamily="34" charset="-120"/>
+                        </a:rPr>
+                        <a:t>עד שעה</a:t>
+                      </a:r>
+                      <a:endParaRPr lang="en-US" sz="1300" dirty="0">
+                        <a:latin typeface="Arial" charset="0"/>
+                        <a:ea typeface="Arial" charset="0"/>
+                        <a:cs typeface="Arial" charset="0"/>
+                      </a:endParaRPr>
+                    </a:p>
+                  </a:txBody>
+                  <a:tcPr marL="54864" marR="54864" marT="54864" marB="54864" anchor="ctr">
+                    <a:lnL w="9525" cap="flat" cmpd="sng" algn="ctr">
+                      <a:solidFill>
+                        <a:srgbClr val="D5E3DF"/>
+                      </a:solidFill>
+                      <a:prstDash val="solid"/>
+                      <a:round/>
+                      <a:headEnd type="none" w="med" len="med"/>
+                      <a:tailEnd type="none" w="med" len="med"/>
+                    </a:lnL>
+                    <a:lnR w="9525" cap="flat" cmpd="sng" algn="ctr">
+                      <a:solidFill>
+                        <a:srgbClr val="D5E3DF"/>
+                      </a:solidFill>
+                      <a:prstDash val="solid"/>
+                      <a:round/>
+                      <a:headEnd type="none" w="med" len="med"/>
+                      <a:tailEnd type="none" w="med" len="med"/>
+                    </a:lnR>
+                    <a:lnT w="9525" cap="flat" cmpd="sng" algn="ctr">
+                      <a:solidFill>
+                        <a:srgbClr val="D5E3DF"/>
+                      </a:solidFill>
+                      <a:prstDash val="solid"/>
+                      <a:round/>
+                      <a:headEnd type="none" w="med" len="med"/>
+                      <a:tailEnd type="none" w="med" len="med"/>
+                    </a:lnT>
+                    <a:lnB w="9525" cap="flat" cmpd="sng" algn="ctr">
+                      <a:solidFill>
+                        <a:srgbClr val="D5E3DF"/>
+                      </a:solidFill>
+                      <a:prstDash val="solid"/>
+                      <a:round/>
+                      <a:headEnd type="none" w="med" len="med"/>
+                      <a:tailEnd type="none" w="med" len="med"/>
+                    </a:lnB>
+                    <a:solidFill>
+                      <a:srgbClr val="F4FAF8"/>
+                    </a:solidFill>
+                  </a:tcPr>
+                </a:tc>
+                <a:tc>
+                  <a:txBody>
+                    <a:bodyPr/>
+                    <a:lstStyle/>
+                    <a:p>
+                      <a:pPr algn="ctr" indent="0" marL="0">
+                        <a:buNone/>
+                      </a:pPr>
+                      <a:r>
+                        <a:rPr lang="en-US" sz="1300" dirty="0">
+                          <a:solidFill>
+                            <a:srgbClr val="1F2937"/>
+                          </a:solidFill>
+                          <a:latin typeface="Arial" pitchFamily="34" charset="0"/>
+                          <a:ea typeface="Arial" pitchFamily="34" charset="-122"/>
+                          <a:cs typeface="Arial" pitchFamily="34" charset="-120"/>
+                        </a:rPr>
+                        <a:t>יום עבודה מלא</a:t>
+                      </a:r>
+                      <a:endParaRPr lang="en-US" sz="1300" dirty="0">
+                        <a:latin typeface="Arial" charset="0"/>
+                        <a:ea typeface="Arial" charset="0"/>
+                        <a:cs typeface="Arial" charset="0"/>
+                      </a:endParaRPr>
+                    </a:p>
+                  </a:txBody>
+                  <a:tcPr marL="54864" marR="54864" marT="54864" marB="54864" anchor="ctr">
+                    <a:lnL w="9525" cap="flat" cmpd="sng" algn="ctr">
+                      <a:solidFill>
+                        <a:srgbClr val="D5E3DF"/>
+                      </a:solidFill>
+                      <a:prstDash val="solid"/>
+                      <a:round/>
+                      <a:headEnd type="none" w="med" len="med"/>
+                      <a:tailEnd type="none" w="med" len="med"/>
+                    </a:lnL>
+                    <a:lnR w="9525" cap="flat" cmpd="sng" algn="ctr">
+                      <a:solidFill>
+                        <a:srgbClr val="D5E3DF"/>
+                      </a:solidFill>
+                      <a:prstDash val="solid"/>
+                      <a:round/>
+                      <a:headEnd type="none" w="med" len="med"/>
+                      <a:tailEnd type="none" w="med" len="med"/>
+                    </a:lnR>
+                    <a:lnT w="9525" cap="flat" cmpd="sng" algn="ctr">
+                      <a:solidFill>
+                        <a:srgbClr val="D5E3DF"/>
+                      </a:solidFill>
+                      <a:prstDash val="solid"/>
+                      <a:round/>
+                      <a:headEnd type="none" w="med" len="med"/>
+                      <a:tailEnd type="none" w="med" len="med"/>
+                    </a:lnT>
+                    <a:lnB w="9525" cap="flat" cmpd="sng" algn="ctr">
+                      <a:solidFill>
+                        <a:srgbClr val="D5E3DF"/>
+                      </a:solidFill>
+                      <a:prstDash val="solid"/>
+                      <a:round/>
+                      <a:headEnd type="none" w="med" len="med"/>
+                      <a:tailEnd type="none" w="med" len="med"/>
+                    </a:lnB>
+                    <a:solidFill>
+                      <a:srgbClr val="F4FAF8"/>
+                    </a:solidFill>
+                  </a:tcPr>
+                </a:tc>
+                <a:tc>
+                  <a:txBody>
+                    <a:bodyPr/>
+                    <a:lstStyle/>
+                    <a:p>
+                      <a:pPr algn="r" indent="0" marL="0">
+                        <a:buNone/>
+                      </a:pPr>
+                      <a:r>
+                        <a:rPr lang="en-US" sz="1300" b="1" dirty="0">
+                          <a:solidFill>
+                            <a:srgbClr val="1F2937"/>
+                          </a:solidFill>
+                          <a:latin typeface="Arial" pitchFamily="34" charset="0"/>
+                          <a:ea typeface="Arial" pitchFamily="34" charset="-122"/>
+                          <a:cs typeface="Arial" pitchFamily="34" charset="-120"/>
+                        </a:rPr>
+                        <a:t>הפקת דוח שכר חודשי</a:t>
+                      </a:r>
+                      <a:endParaRPr lang="en-US" sz="1300" dirty="0">
+                        <a:latin typeface="Arial" charset="0"/>
+                        <a:ea typeface="Arial" charset="0"/>
+                        <a:cs typeface="Arial" charset="0"/>
+                      </a:endParaRPr>
+                    </a:p>
+                  </a:txBody>
+                  <a:tcPr marL="54864" marR="54864" marT="54864" marB="54864" anchor="ctr">
+                    <a:lnL w="9525" cap="flat" cmpd="sng" algn="ctr">
+                      <a:solidFill>
+                        <a:srgbClr val="D5E3DF"/>
+                      </a:solidFill>
+                      <a:prstDash val="solid"/>
+                      <a:round/>
+                      <a:headEnd type="none" w="med" len="med"/>
+                      <a:tailEnd type="none" w="med" len="med"/>
+                    </a:lnL>
+                    <a:lnR w="9525" cap="flat" cmpd="sng" algn="ctr">
+                      <a:solidFill>
+                        <a:srgbClr val="D5E3DF"/>
+                      </a:solidFill>
+                      <a:prstDash val="solid"/>
+                      <a:round/>
+                      <a:headEnd type="none" w="med" len="med"/>
+                      <a:tailEnd type="none" w="med" len="med"/>
+                    </a:lnR>
+                    <a:lnT w="9525" cap="flat" cmpd="sng" algn="ctr">
+                      <a:solidFill>
+                        <a:srgbClr val="D5E3DF"/>
+                      </a:solidFill>
+                      <a:prstDash val="solid"/>
+                      <a:round/>
+                      <a:headEnd type="none" w="med" len="med"/>
+                      <a:tailEnd type="none" w="med" len="med"/>
+                    </a:lnT>
+                    <a:lnB w="9525" cap="flat" cmpd="sng" algn="ctr">
+                      <a:solidFill>
+                        <a:srgbClr val="D5E3DF"/>
+                      </a:solidFill>
+                      <a:prstDash val="solid"/>
+                      <a:round/>
+                      <a:headEnd type="none" w="med" len="med"/>
+                      <a:tailEnd type="none" w="med" len="med"/>
+                    </a:lnB>
+                    <a:solidFill>
+                      <a:srgbClr val="F4FAF8"/>
+                    </a:solidFill>
+                  </a:tcPr>
+                </a:tc>
+              </a:tr>
+              <a:tr h="530352">
+                <a:tc>
+                  <a:txBody>
+                    <a:bodyPr/>
+                    <a:lstStyle/>
+                    <a:p>
+                      <a:pPr algn="ctr" indent="0" marL="0">
+                        <a:buNone/>
+                      </a:pPr>
+                      <a:r>
+                        <a:rPr lang="en-US" sz="1300" b="1" dirty="0">
+                          <a:solidFill>
+                            <a:srgbClr val="0F4C46"/>
+                          </a:solidFill>
+                          <a:latin typeface="Arial" pitchFamily="34" charset="0"/>
+                          <a:ea typeface="Arial" pitchFamily="34" charset="-122"/>
+                          <a:cs typeface="Arial" pitchFamily="34" charset="-120"/>
+                        </a:rPr>
+                        <a:t>זמינים בכל רגע</a:t>
+                      </a:r>
+                      <a:endParaRPr lang="en-US" sz="1300" dirty="0">
+                        <a:latin typeface="Arial" charset="0"/>
+                        <a:ea typeface="Arial" charset="0"/>
+                        <a:cs typeface="Arial" charset="0"/>
+                      </a:endParaRPr>
+                    </a:p>
+                  </a:txBody>
+                  <a:tcPr marL="54864" marR="54864" marT="54864" marB="54864" anchor="ctr">
+                    <a:lnL w="9525" cap="flat" cmpd="sng" algn="ctr">
+                      <a:solidFill>
+                        <a:srgbClr val="D5E3DF"/>
+                      </a:solidFill>
+                      <a:prstDash val="solid"/>
+                      <a:round/>
+                      <a:headEnd type="none" w="med" len="med"/>
+                      <a:tailEnd type="none" w="med" len="med"/>
+                    </a:lnL>
+                    <a:lnR w="9525" cap="flat" cmpd="sng" algn="ctr">
+                      <a:solidFill>
+                        <a:srgbClr val="D5E3DF"/>
+                      </a:solidFill>
+                      <a:prstDash val="solid"/>
+                      <a:round/>
+                      <a:headEnd type="none" w="med" len="med"/>
+                      <a:tailEnd type="none" w="med" len="med"/>
+                    </a:lnR>
+                    <a:lnT w="9525" cap="flat" cmpd="sng" algn="ctr">
+                      <a:solidFill>
+                        <a:srgbClr val="D5E3DF"/>
+                      </a:solidFill>
+                      <a:prstDash val="solid"/>
+                      <a:round/>
+                      <a:headEnd type="none" w="med" len="med"/>
+                      <a:tailEnd type="none" w="med" len="med"/>
+                    </a:lnT>
+                    <a:lnB w="9525" cap="flat" cmpd="sng" algn="ctr">
+                      <a:solidFill>
+                        <a:srgbClr val="D5E3DF"/>
+                      </a:solidFill>
+                      <a:prstDash val="solid"/>
+                      <a:round/>
+                      <a:headEnd type="none" w="med" len="med"/>
+                      <a:tailEnd type="none" w="med" len="med"/>
+                    </a:lnB>
+                    <a:solidFill>
+                      <a:srgbClr val="FFFFFF"/>
+                    </a:solidFill>
+                  </a:tcPr>
+                </a:tc>
+                <a:tc>
+                  <a:txBody>
+                    <a:bodyPr/>
+                    <a:lstStyle/>
+                    <a:p>
+                      <a:pPr algn="ctr" indent="0" marL="0">
+                        <a:buNone/>
+                      </a:pPr>
+                      <a:r>
+                        <a:rPr lang="en-US" sz="1300" dirty="0">
+                          <a:solidFill>
+                            <a:srgbClr val="1F2937"/>
+                          </a:solidFill>
+                          <a:latin typeface="Arial" pitchFamily="34" charset="0"/>
+                          <a:ea typeface="Arial" pitchFamily="34" charset="-122"/>
+                          <a:cs typeface="Arial" pitchFamily="34" charset="-120"/>
+                        </a:rPr>
+                        <a:t>אינם קיימים</a:t>
+                      </a:r>
+                      <a:endParaRPr lang="en-US" sz="1300" dirty="0">
+                        <a:latin typeface="Arial" charset="0"/>
+                        <a:ea typeface="Arial" charset="0"/>
+                        <a:cs typeface="Arial" charset="0"/>
+                      </a:endParaRPr>
+                    </a:p>
+                  </a:txBody>
+                  <a:tcPr marL="54864" marR="54864" marT="54864" marB="54864" anchor="ctr">
+                    <a:lnL w="9525" cap="flat" cmpd="sng" algn="ctr">
+                      <a:solidFill>
+                        <a:srgbClr val="D5E3DF"/>
+                      </a:solidFill>
+                      <a:prstDash val="solid"/>
+                      <a:round/>
+                      <a:headEnd type="none" w="med" len="med"/>
+                      <a:tailEnd type="none" w="med" len="med"/>
+                    </a:lnL>
+                    <a:lnR w="9525" cap="flat" cmpd="sng" algn="ctr">
+                      <a:solidFill>
+                        <a:srgbClr val="D5E3DF"/>
+                      </a:solidFill>
+                      <a:prstDash val="solid"/>
+                      <a:round/>
+                      <a:headEnd type="none" w="med" len="med"/>
+                      <a:tailEnd type="none" w="med" len="med"/>
+                    </a:lnR>
+                    <a:lnT w="9525" cap="flat" cmpd="sng" algn="ctr">
+                      <a:solidFill>
+                        <a:srgbClr val="D5E3DF"/>
+                      </a:solidFill>
+                      <a:prstDash val="solid"/>
+                      <a:round/>
+                      <a:headEnd type="none" w="med" len="med"/>
+                      <a:tailEnd type="none" w="med" len="med"/>
+                    </a:lnT>
+                    <a:lnB w="9525" cap="flat" cmpd="sng" algn="ctr">
+                      <a:solidFill>
+                        <a:srgbClr val="D5E3DF"/>
+                      </a:solidFill>
+                      <a:prstDash val="solid"/>
+                      <a:round/>
+                      <a:headEnd type="none" w="med" len="med"/>
+                      <a:tailEnd type="none" w="med" len="med"/>
+                    </a:lnB>
+                    <a:solidFill>
+                      <a:srgbClr val="FFFFFF"/>
+                    </a:solidFill>
+                  </a:tcPr>
+                </a:tc>
+                <a:tc>
+                  <a:txBody>
+                    <a:bodyPr/>
+                    <a:lstStyle/>
+                    <a:p>
+                      <a:pPr algn="r" indent="0" marL="0">
+                        <a:buNone/>
+                      </a:pPr>
+                      <a:r>
+                        <a:rPr lang="en-US" sz="1300" b="1" dirty="0">
+                          <a:solidFill>
+                            <a:srgbClr val="1F2937"/>
+                          </a:solidFill>
+                          <a:latin typeface="Arial" pitchFamily="34" charset="0"/>
+                          <a:ea typeface="Arial" pitchFamily="34" charset="-122"/>
+                          <a:cs typeface="Arial" pitchFamily="34" charset="-120"/>
+                        </a:rPr>
+                        <a:t>דוחות ניהוליים להנהלה</a:t>
+                      </a:r>
+                      <a:endParaRPr lang="en-US" sz="1300" dirty="0">
+                        <a:latin typeface="Arial" charset="0"/>
+                        <a:ea typeface="Arial" charset="0"/>
+                        <a:cs typeface="Arial" charset="0"/>
+                      </a:endParaRPr>
+                    </a:p>
+                  </a:txBody>
+                  <a:tcPr marL="54864" marR="54864" marT="54864" marB="54864" anchor="ctr">
+                    <a:lnL w="9525" cap="flat" cmpd="sng" algn="ctr">
+                      <a:solidFill>
+                        <a:srgbClr val="D5E3DF"/>
+                      </a:solidFill>
+                      <a:prstDash val="solid"/>
+                      <a:round/>
+                      <a:headEnd type="none" w="med" len="med"/>
+                      <a:tailEnd type="none" w="med" len="med"/>
+                    </a:lnL>
+                    <a:lnR w="9525" cap="flat" cmpd="sng" algn="ctr">
+                      <a:solidFill>
+                        <a:srgbClr val="D5E3DF"/>
+                      </a:solidFill>
+                      <a:prstDash val="solid"/>
+                      <a:round/>
+                      <a:headEnd type="none" w="med" len="med"/>
+                      <a:tailEnd type="none" w="med" len="med"/>
+                    </a:lnR>
+                    <a:lnT w="9525" cap="flat" cmpd="sng" algn="ctr">
+                      <a:solidFill>
+                        <a:srgbClr val="D5E3DF"/>
+                      </a:solidFill>
+                      <a:prstDash val="solid"/>
+                      <a:round/>
+                      <a:headEnd type="none" w="med" len="med"/>
+                      <a:tailEnd type="none" w="med" len="med"/>
+                    </a:lnT>
+                    <a:lnB w="9525" cap="flat" cmpd="sng" algn="ctr">
+                      <a:solidFill>
+                        <a:srgbClr val="D5E3DF"/>
+                      </a:solidFill>
+                      <a:prstDash val="solid"/>
+                      <a:round/>
+                      <a:headEnd type="none" w="med" len="med"/>
+                      <a:tailEnd type="none" w="med" len="med"/>
+                    </a:lnB>
+                    <a:solidFill>
+                      <a:srgbClr val="FFFFFF"/>
+                    </a:solidFill>
+                  </a:tcPr>
+                </a:tc>
+              </a:tr>
+            </a:tbl>
+          </a:graphicData>
+        </a:graphic>
+      </p:graphicFrame>
+      <p:sp>
+        <p:nvSpPr>
+          <p:cNvPr id="5" name="Text 2"/>
+          <p:cNvSpPr/>
+          <p:nvPr/>
+        </p:nvSpPr>
+        <p:spPr>
+          <a:xfrm>
+            <a:off x="502920" y="5897880"/>
+            <a:ext cx="11183112" cy="411480"/>
           </a:xfrm>
           <a:prstGeom prst="rect">
             <a:avLst/>
@@ -8615,23 +9610,23 @@
               <a:buNone/>
             </a:pPr>
             <a:r>
-              <a:rPr lang="en-US" sz="1500" i="1" dirty="0">
-                <a:solidFill>
-                  <a:srgbClr val="0F4C46"/>
-                </a:solidFill>
-                <a:latin typeface="Arial" pitchFamily="34" charset="0"/>
-                <a:ea typeface="Arial" pitchFamily="34" charset="-122"/>
-                <a:cs typeface="Arial" pitchFamily="34" charset="-120"/>
-              </a:rPr>
-              <a:t>ובנוסף: עדכון מיידי של כל עובד על שיבוצו, ותמונת מצב ניהולית זמינה בכל רגע</a:t>
-            </a:r>
-            <a:endParaRPr lang="en-US" sz="1500" dirty="0"/>
-          </a:p>
-        </p:txBody>
-      </p:sp>
-      <p:sp>
-        <p:nvSpPr>
-          <p:cNvPr id="25" name="Text 23"/>
+              <a:rPr lang="en-US" sz="1300" i="1" dirty="0">
+                <a:solidFill>
+                  <a:srgbClr val="5B6B68"/>
+                </a:solidFill>
+                <a:latin typeface="Arial" pitchFamily="34" charset="0"/>
+                <a:ea typeface="Arial" pitchFamily="34" charset="-122"/>
+                <a:cs typeface="Arial" pitchFamily="34" charset="-120"/>
+              </a:rPr>
+              <a:t>היעדים הוגדרו יחד עם בעל החברה בשלב ההצעה, והם ישמשו למדידת הצלחת המערכת לאחר הטמעתה</a:t>
+            </a:r>
+            <a:endParaRPr lang="en-US" sz="1300" dirty="0"/>
+          </a:p>
+        </p:txBody>
+      </p:sp>
+      <p:sp>
+        <p:nvSpPr>
+          <p:cNvPr id="6" name="Text 3"/>
           <p:cNvSpPr/>
           <p:nvPr/>
         </p:nvSpPr>
@@ -8665,6 +9660,45 @@
               <a:t>4</a:t>
             </a:r>
             <a:endParaRPr lang="en-US" sz="1000" dirty="0"/>
+          </a:p>
+        </p:txBody>
+      </p:sp>
+      <p:sp>
+        <p:nvSpPr>
+          <p:cNvPr id="7" name="Text 4"/>
+          <p:cNvSpPr/>
+          <p:nvPr/>
+        </p:nvSpPr>
+        <p:spPr>
+          <a:xfrm>
+            <a:off x="320040" y="6400800"/>
+            <a:ext cx="5120640" cy="274320"/>
+          </a:xfrm>
+          <a:prstGeom prst="rect">
+            <a:avLst/>
+          </a:prstGeom>
+          <a:noFill/>
+          <a:ln/>
+        </p:spPr>
+        <p:txBody>
+          <a:bodyPr wrap="square" lIns="0" tIns="0" rIns="0" bIns="0" rtlCol="0" anchor="ctr"/>
+          <a:lstStyle/>
+          <a:p>
+            <a:pPr rtl="1" algn="l" indent="0" marL="0">
+              <a:buNone/>
+            </a:pPr>
+            <a:r>
+              <a:rPr lang="en-US" sz="900" dirty="0">
+                <a:solidFill>
+                  <a:srgbClr val="9AA7A4"/>
+                </a:solidFill>
+                <a:latin typeface="Arial" pitchFamily="34" charset="0"/>
+                <a:ea typeface="Arial" pitchFamily="34" charset="-122"/>
+                <a:cs typeface="Arial" pitchFamily="34" charset="-120"/>
+              </a:rPr>
+              <a:t>פרקטיקום בניהול מערכות מידע, תשפ"ו | ס.א הנדסה | כאמל עואד</a:t>
+            </a:r>
+            <a:endParaRPr lang="en-US" sz="900" dirty="0"/>
           </a:p>
         </p:txBody>
       </p:sp>
@@ -9196,6 +10230,45 @@
           </a:p>
         </p:txBody>
       </p:sp>
+      <p:sp>
+        <p:nvSpPr>
+          <p:cNvPr id="10" name="Text 8"/>
+          <p:cNvSpPr/>
+          <p:nvPr/>
+        </p:nvSpPr>
+        <p:spPr>
+          <a:xfrm>
+            <a:off x="320040" y="6400800"/>
+            <a:ext cx="5120640" cy="274320"/>
+          </a:xfrm>
+          <a:prstGeom prst="rect">
+            <a:avLst/>
+          </a:prstGeom>
+          <a:noFill/>
+          <a:ln/>
+        </p:spPr>
+        <p:txBody>
+          <a:bodyPr wrap="square" lIns="0" tIns="0" rIns="0" bIns="0" rtlCol="0" anchor="ctr"/>
+          <a:lstStyle/>
+          <a:p>
+            <a:pPr rtl="1" algn="l" indent="0" marL="0">
+              <a:buNone/>
+            </a:pPr>
+            <a:r>
+              <a:rPr lang="en-US" sz="900" dirty="0">
+                <a:solidFill>
+                  <a:srgbClr val="9AA7A4"/>
+                </a:solidFill>
+                <a:latin typeface="Arial" pitchFamily="34" charset="0"/>
+                <a:ea typeface="Arial" pitchFamily="34" charset="-122"/>
+                <a:cs typeface="Arial" pitchFamily="34" charset="-120"/>
+              </a:rPr>
+              <a:t>פרקטיקום בניהול מערכות מידע, תשפ"ו | ס.א הנדסה | כאמל עואד</a:t>
+            </a:r>
+            <a:endParaRPr lang="en-US" sz="900" dirty="0"/>
+          </a:p>
+        </p:txBody>
+      </p:sp>
     </p:spTree>
   </p:cSld>
   <p:clrMapOvr>
@@ -10374,6 +11447,45 @@
           </a:p>
         </p:txBody>
       </p:sp>
+      <p:sp>
+        <p:nvSpPr>
+          <p:cNvPr id="36" name="Text 34"/>
+          <p:cNvSpPr/>
+          <p:nvPr/>
+        </p:nvSpPr>
+        <p:spPr>
+          <a:xfrm>
+            <a:off x="320040" y="6400800"/>
+            <a:ext cx="5120640" cy="274320"/>
+          </a:xfrm>
+          <a:prstGeom prst="rect">
+            <a:avLst/>
+          </a:prstGeom>
+          <a:noFill/>
+          <a:ln/>
+        </p:spPr>
+        <p:txBody>
+          <a:bodyPr wrap="square" lIns="0" tIns="0" rIns="0" bIns="0" rtlCol="0" anchor="ctr"/>
+          <a:lstStyle/>
+          <a:p>
+            <a:pPr rtl="1" algn="l" indent="0" marL="0">
+              <a:buNone/>
+            </a:pPr>
+            <a:r>
+              <a:rPr lang="en-US" sz="900" dirty="0">
+                <a:solidFill>
+                  <a:srgbClr val="9AA7A4"/>
+                </a:solidFill>
+                <a:latin typeface="Arial" pitchFamily="34" charset="0"/>
+                <a:ea typeface="Arial" pitchFamily="34" charset="-122"/>
+                <a:cs typeface="Arial" pitchFamily="34" charset="-120"/>
+              </a:rPr>
+              <a:t>פרקטיקום בניהול מערכות מידע, תשפ"ו | ס.א הנדסה | כאמל עואד</a:t>
+            </a:r>
+            <a:endParaRPr lang="en-US" sz="900" dirty="0"/>
+          </a:p>
+        </p:txBody>
+      </p:sp>
     </p:spTree>
   </p:cSld>
   <p:clrMapOvr>
@@ -10439,15 +11551,54 @@
                 <a:ea typeface="Arial" pitchFamily="34" charset="-122"/>
                 <a:cs typeface="Arial" pitchFamily="34" charset="-120"/>
               </a:rPr>
-              <a:t>תוכנית העבודה: 31 פעילויות, כל אבני הדרך נשמרו</a:t>
+              <a:t>תוכנית העבודה ותרשים הגאנט, סטטוס 30.6.2026</a:t>
             </a:r>
             <a:endParaRPr lang="en-US" sz="3000" dirty="0"/>
+          </a:p>
+        </p:txBody>
+      </p:sp>
+      <p:sp>
+        <p:nvSpPr>
+          <p:cNvPr id="3" name="Text 1"/>
+          <p:cNvSpPr/>
+          <p:nvPr/>
+        </p:nvSpPr>
+        <p:spPr>
+          <a:xfrm>
+            <a:off x="502920" y="987552"/>
+            <a:ext cx="11183112" cy="548640"/>
+          </a:xfrm>
+          <a:prstGeom prst="rect">
+            <a:avLst/>
+          </a:prstGeom>
+          <a:noFill/>
+          <a:ln/>
+        </p:spPr>
+        <p:txBody>
+          <a:bodyPr wrap="square" lIns="0" tIns="0" rIns="0" bIns="0" rtlCol="0" anchor="ctr"/>
+          <a:lstStyle/>
+          <a:p>
+            <a:pPr rtl="1" algn="r" indent="0" marL="0">
+              <a:buNone/>
+            </a:pPr>
+            <a:r>
+              <a:rPr lang="en-US" sz="1400" dirty="0">
+                <a:solidFill>
+                  <a:srgbClr val="5B6B68"/>
+                </a:solidFill>
+                <a:latin typeface="Arial" pitchFamily="34" charset="0"/>
+                <a:ea typeface="Arial" pitchFamily="34" charset="-122"/>
+                <a:cs typeface="Arial" pitchFamily="34" charset="-120"/>
+              </a:rPr>
+              <a:t>התוכנית כוללת 31 פעילויות בארבעה שלבים, עם תלות בין הפעילויות ומרווחי ביטחון לפני כל הגשה. בירוק: מה שבוצע; בתכלת: המתוכנן להמשך. כל מועדי ההגשה נשמרו.</a:t>
+            </a:r>
+            <a:endParaRPr lang="en-US" sz="1400" dirty="0"/>
           </a:p>
         </p:txBody>
       </p:sp>
       <p:pic>
         <p:nvPicPr>
-          <p:cNvPr id="3" name="Image 0" descr="gantt_status.png">    </p:cNvPr>
+          <p:cNvPr id="4" name="Image 0" descr="gantt_status.png">    </p:cNvPr>
           <p:cNvPicPr>
             <a:picLocks noChangeAspect="1"/>
           </p:cNvPicPr>
@@ -10461,8 +11612,8 @@
         </p:blipFill>
         <p:spPr>
           <a:xfrm>
-            <a:off x="1143000" y="1143000"/>
-            <a:ext cx="9902952" cy="5532120"/>
+            <a:off x="1417320" y="1600200"/>
+            <a:ext cx="9354312" cy="4892040"/>
           </a:xfrm>
           <a:prstGeom prst="rect">
             <a:avLst/>
@@ -10471,7 +11622,7 @@
       </p:pic>
       <p:sp>
         <p:nvSpPr>
-          <p:cNvPr id="4" name="Text 1"/>
+          <p:cNvPr id="5" name="Text 2"/>
           <p:cNvSpPr/>
           <p:nvPr/>
         </p:nvSpPr>
@@ -10505,6 +11656,45 @@
               <a:t>7</a:t>
             </a:r>
             <a:endParaRPr lang="en-US" sz="1000" dirty="0"/>
+          </a:p>
+        </p:txBody>
+      </p:sp>
+      <p:sp>
+        <p:nvSpPr>
+          <p:cNvPr id="6" name="Text 3"/>
+          <p:cNvSpPr/>
+          <p:nvPr/>
+        </p:nvSpPr>
+        <p:spPr>
+          <a:xfrm>
+            <a:off x="320040" y="6400800"/>
+            <a:ext cx="5120640" cy="274320"/>
+          </a:xfrm>
+          <a:prstGeom prst="rect">
+            <a:avLst/>
+          </a:prstGeom>
+          <a:noFill/>
+          <a:ln/>
+        </p:spPr>
+        <p:txBody>
+          <a:bodyPr wrap="square" lIns="0" tIns="0" rIns="0" bIns="0" rtlCol="0" anchor="ctr"/>
+          <a:lstStyle/>
+          <a:p>
+            <a:pPr rtl="1" algn="l" indent="0" marL="0">
+              <a:buNone/>
+            </a:pPr>
+            <a:r>
+              <a:rPr lang="en-US" sz="900" dirty="0">
+                <a:solidFill>
+                  <a:srgbClr val="9AA7A4"/>
+                </a:solidFill>
+                <a:latin typeface="Arial" pitchFamily="34" charset="0"/>
+                <a:ea typeface="Arial" pitchFamily="34" charset="-122"/>
+                <a:cs typeface="Arial" pitchFamily="34" charset="-120"/>
+              </a:rPr>
+              <a:t>פרקטיקום בניהול מערכות מידע, תשפ"ו | ס.א הנדסה | כאמל עואד</a:t>
+            </a:r>
+            <a:endParaRPr lang="en-US" sz="900" dirty="0"/>
           </a:p>
         </p:txBody>
       </p:sp>
@@ -10573,7 +11763,7 @@
                 <a:ea typeface="Arial" pitchFamily="34" charset="-122"/>
                 <a:cs typeface="Arial" pitchFamily="34" charset="-120"/>
               </a:rPr>
-              <a:t>איפיון: התהליך הארגוני מקצה לקצה</a:t>
+              <a:t>איפיון: התהליך הארגוני המרכזי</a:t>
             </a:r>
             <a:endParaRPr lang="en-US" sz="3000" dirty="0"/>
           </a:p>
@@ -10595,8 +11785,8 @@
         </p:blipFill>
         <p:spPr>
           <a:xfrm>
-            <a:off x="1463040" y="1325880"/>
-            <a:ext cx="9262872" cy="5074920"/>
+            <a:off x="1783080" y="1234440"/>
+            <a:ext cx="8622792" cy="4727448"/>
           </a:xfrm>
           <a:prstGeom prst="rect">
             <a:avLst/>
@@ -10606,6 +11796,45 @@
       <p:sp>
         <p:nvSpPr>
           <p:cNvPr id="4" name="Text 1"/>
+          <p:cNvSpPr/>
+          <p:nvPr/>
+        </p:nvSpPr>
+        <p:spPr>
+          <a:xfrm>
+            <a:off x="777240" y="6035040"/>
+            <a:ext cx="10634472" cy="640080"/>
+          </a:xfrm>
+          <a:prstGeom prst="rect">
+            <a:avLst/>
+          </a:prstGeom>
+          <a:noFill/>
+          <a:ln/>
+        </p:spPr>
+        <p:txBody>
+          <a:bodyPr wrap="square" lIns="0" tIns="0" rIns="0" bIns="0" rtlCol="0" anchor="ctr"/>
+          <a:lstStyle/>
+          <a:p>
+            <a:pPr rtl="1" algn="ctr" indent="0" marL="0">
+              <a:buNone/>
+            </a:pPr>
+            <a:r>
+              <a:rPr lang="en-US" sz="1300" dirty="0">
+                <a:solidFill>
+                  <a:srgbClr val="5B6B68"/>
+                </a:solidFill>
+                <a:latin typeface="Arial" pitchFamily="34" charset="0"/>
+                <a:ea typeface="Arial" pitchFamily="34" charset="-122"/>
+                <a:cs typeface="Arial" pitchFamily="34" charset="-120"/>
+              </a:rPr>
+              <a:t>התהליך שמופה בראיונות ובתצפית: מקבלת הפנייה, דרך השמאות והצעת המחיר, ועד הביצוע, המסירה והגבייה. המערכת מתעדת ומנהלת כל תחנה בתהליך; העבודה הפיזית עצמה נשארת מחוץ לתחולה.</a:t>
+            </a:r>
+            <a:endParaRPr lang="en-US" sz="1300" dirty="0"/>
+          </a:p>
+        </p:txBody>
+      </p:sp>
+      <p:sp>
+        <p:nvSpPr>
+          <p:cNvPr id="5" name="Text 2"/>
           <p:cNvSpPr/>
           <p:nvPr/>
         </p:nvSpPr>
@@ -10961,6 +12190,45 @@
               <a:t>9</a:t>
             </a:r>
             <a:endParaRPr lang="en-US" sz="1000" dirty="0"/>
+          </a:p>
+        </p:txBody>
+      </p:sp>
+      <p:sp>
+        <p:nvSpPr>
+          <p:cNvPr id="8" name="Text 5"/>
+          <p:cNvSpPr/>
+          <p:nvPr/>
+        </p:nvSpPr>
+        <p:spPr>
+          <a:xfrm>
+            <a:off x="320040" y="6400800"/>
+            <a:ext cx="5120640" cy="274320"/>
+          </a:xfrm>
+          <a:prstGeom prst="rect">
+            <a:avLst/>
+          </a:prstGeom>
+          <a:noFill/>
+          <a:ln/>
+        </p:spPr>
+        <p:txBody>
+          <a:bodyPr wrap="square" lIns="0" tIns="0" rIns="0" bIns="0" rtlCol="0" anchor="ctr"/>
+          <a:lstStyle/>
+          <a:p>
+            <a:pPr rtl="1" algn="l" indent="0" marL="0">
+              <a:buNone/>
+            </a:pPr>
+            <a:r>
+              <a:rPr lang="en-US" sz="900" dirty="0">
+                <a:solidFill>
+                  <a:srgbClr val="9AA7A4"/>
+                </a:solidFill>
+                <a:latin typeface="Arial" pitchFamily="34" charset="0"/>
+                <a:ea typeface="Arial" pitchFamily="34" charset="-122"/>
+                <a:cs typeface="Arial" pitchFamily="34" charset="-120"/>
+              </a:rPr>
+              <a:t>פרקטיקום בניהול מערכות מידע, תשפ"ו | ס.א הנדסה | כאמל עואד</a:t>
+            </a:r>
+            <a:endParaRPr lang="en-US" sz="900" dirty="0"/>
           </a:p>
         </p:txBody>
       </p:sp>

</xml_diff>